<commit_message>
Informe técnico y presentación de la Actividad 2 con la nueva interfaz
- Informe APA 7 rehecho: sección «Interfaz con Bootstrap 5: modales, avisos y paleta pastel»,
  prueba de punta a punta en Edge, error de sesión/CSRF y su corrección, RF-10 y RNF-11,
  tablero actualizado, integrantes y docente (37 págs., 11 tablas, 15 figuras).
- Presentación de 14 diapositivas con la paleta pastel y una diapositiva de la nueva interfaz.
- Capturas de docs/actividad-02/capturas tomadas de nuevo con el diseño actual.
- Bitácora de IA: entrada 18.

Co-Authored-By: Claude Opus 5.5 <noreply@anthropic.com>
</commit_message>
<xml_diff>
--- a/docs/actividad-02/Presentacion_Actividad02.pptx
+++ b/docs/actividad-02/Presentacion_Actividad02.pptx
@@ -18,9 +18,10 @@
     <p:sldId id="266" r:id="rId12"/>
     <p:sldId id="267" r:id="rId13"/>
     <p:sldId id="268" r:id="rId14"/>
+    <p:sldId id="269" r:id="rId15"/>
   </p:sldIdLst>
   <p:notesMasterIdLst>
-    <p:notesMasterId r:id="rId15"/>
+    <p:notesMasterId r:id="rId16"/>
   </p:notesMasterIdLst>
   <p:sldSz cx="12192000" cy="6858000"/>
   <p:notesSz cx="6858000" cy="12192000"/>
@@ -119,53 +120,54 @@
   <p:extLst>
     <p:ext uri="{521415D9-36F7-43E2-AB2F-B90AF26B5E84}">
       <p14:sectionLst xmlns:p14="http://schemas.microsoft.com/office/powerpoint/2010/main">
-        <p14:section name="Inicio" id="{fe1756bc-d51a-bf50-f69a-57ccdf763a4b}">
+        <p14:section name="Inicio" id="{bc14d560-7dbd-03a6-c2be-13484fa2a3e2}">
           <p14:sldIdLst>
             <p14:sldId id="256"/>
           </p14:sldIdLst>
         </p14:section>
-        <p14:section name="Contexto" id="{a1f9fd2b-82f7-eaa9-c8db-a1ead7d912b8}">
+        <p14:section name="Contexto" id="{17007429-4c08-6a6e-8606-9f8d188d5761}">
           <p14:sldIdLst>
             <p14:sldId id="257"/>
             <p14:sldId id="258"/>
           </p14:sldIdLst>
         </p14:section>
-        <p14:section name="Base de datos" id="{6a62229e-98b5-d7a0-f6a6-d0cbdc4e64dc}">
+        <p14:section name="Base de datos" id="{4b199489-f951-461d-4451-8551cc423a08}">
           <p14:sldIdLst>
             <p14:sldId id="259"/>
             <p14:sldId id="260"/>
           </p14:sldIdLst>
         </p14:section>
-        <p14:section name="Código" id="{a2df1095-2338-c64d-7da0-43b34d6d09ed}">
+        <p14:section name="Código" id="{6754d0c9-4994-c024-889e-29a39a7d3c95}">
           <p14:sldIdLst>
             <p14:sldId id="261"/>
             <p14:sldId id="262"/>
           </p14:sldIdLst>
         </p14:section>
-        <p14:section name="Aplicación" id="{1415a248-4406-a92d-6aaf-eddafbcdb07a}">
+        <p14:section name="Aplicación" id="{b32ba191-02b9-9d73-c6ed-992ec82962b9}">
           <p14:sldIdLst>
             <p14:sldId id="263"/>
             <p14:sldId id="264"/>
-          </p14:sldIdLst>
-        </p14:section>
-        <p14:section name="Seguridad" id="{1eb4717a-c9bd-2520-bb1f-6cff3b932801}">
-          <p14:sldIdLst>
             <p14:sldId id="265"/>
           </p14:sldIdLst>
         </p14:section>
-        <p14:section name="Pruebas" id="{d24e26f0-a119-96dc-b89a-f6480c0cb1db}">
+        <p14:section name="Seguridad" id="{e2c035ca-c8bc-3953-454e-865b2fc25d32}">
           <p14:sldIdLst>
             <p14:sldId id="266"/>
           </p14:sldIdLst>
         </p14:section>
-        <p14:section name="Uso de IA" id="{07cbbb12-af84-59c4-1bb1-77de8ae89da3}">
+        <p14:section name="Pruebas" id="{eef10be1-9480-7fe9-de23-43ec31d810e8}">
           <p14:sldIdLst>
             <p14:sldId id="267"/>
           </p14:sldIdLst>
         </p14:section>
-        <p14:section name="Cierre" id="{757fa902-ba5b-0099-7a13-14968d59df8a}">
+        <p14:section name="Uso de IA" id="{1a392658-4035-2c89-1b5d-4dc0a605f608}">
           <p14:sldIdLst>
             <p14:sldId id="268"/>
+          </p14:sldIdLst>
+        </p14:section>
+        <p14:section name="Cierre" id="{8441c058-8897-dd2f-26f9-e5fa132f904d}">
+          <p14:sldIdLst>
+            <p14:sldId id="269"/>
           </p14:sldIdLst>
         </p14:section>
       </p14:sectionLst>
@@ -191,7 +193,7 @@
             <a:pPr>
               <a:defRPr sz="1500" b="0" i="0" u="none" strike="noStrike">
                 <a:solidFill>
-                  <a:srgbClr val="7A2E14"/>
+                  <a:srgbClr val="3B3542"/>
                 </a:solidFill>
                 <a:latin typeface="+mn-lt"/>
               </a:defRPr>
@@ -199,7 +201,7 @@
             <a:r>
               <a:rPr sz="1500" b="0" i="0" u="none" strike="noStrike">
                 <a:solidFill>
-                  <a:srgbClr val="7A2E14"/>
+                  <a:srgbClr val="3B3542"/>
                 </a:solidFill>
                 <a:latin typeface="+mn-lt"/>
               </a:rPr>
@@ -234,7 +236,7 @@
           </c:tx>
           <c:spPr>
             <a:solidFill>
-              <a:srgbClr val="0F766E"/>
+              <a:srgbClr val="4C7A69"/>
             </a:solidFill>
             <a:effectLst/>
           </c:spPr>
@@ -248,7 +250,7 @@
                 <a:pPr>
                   <a:defRPr b="0" i="0" strike="noStrike" sz="1300" u="none">
                     <a:solidFill>
-                      <a:srgbClr val="2B1A12"/>
+                      <a:srgbClr val="2D2A32"/>
                     </a:solidFill>
                     <a:latin typeface="+mn-lt"/>
                   </a:defRPr>
@@ -334,7 +336,7 @@
               <a:pPr>
                 <a:defRPr b="0" i="0" strike="noStrike" sz="1300" u="none">
                   <a:solidFill>
-                    <a:srgbClr val="2B1A12"/>
+                    <a:srgbClr val="2D2A32"/>
                   </a:solidFill>
                   <a:latin typeface="+mn-lt"/>
                 </a:defRPr>
@@ -382,7 +384,7 @@
             <a:pPr>
               <a:defRPr sz="1300" b="0" i="0" u="none" strike="noStrike">
                 <a:solidFill>
-                  <a:srgbClr val="2B1A12"/>
+                  <a:srgbClr val="2D2A32"/>
                 </a:solidFill>
                 <a:latin typeface="+mn-lt"/>
               </a:defRPr>
@@ -942,7 +944,7 @@
           <a:p>
             <a:r>
               <a:rPr lang="en-US" dirty="0"/>
-              <a:t>Probamos trece ataques automáticos. Ninguno devolvió datos de más ni borró tablas. Además, una prueba revisa el código y falla si alguien concatena una variable dentro de un SQL.</a:t>
+              <a:t>Rediseñamos la interfaz con una paleta pastel de tienda de ropa. El detalle, el registro y la edición se abren en modales; eliminar pide confirmación y el resultado aparece como aviso en la esquina. Una prueba en el navegador encontró un error de sesión que hacía fallar el token CSRF al eliminar, y lo corregimos.</a:t>
             </a:r>
             <a:endParaRPr lang="en-US" dirty="0"/>
           </a:p>
@@ -1030,7 +1032,7 @@
           <a:p>
             <a:r>
               <a:rPr lang="en-US" dirty="0"/>
-              <a:t>Las pruebas crean su propia base de datos y la borran al terminar, así nunca tocan los datos reales. Las ejecutamos en Windows y en el Docker del curso, con el mismo resultado.</a:t>
+              <a:t>Probamos trece ataques automáticos. Ninguno devolvió datos de más ni borró tablas. Además, una prueba revisa el código y falla si alguien concatena una variable dentro de un SQL.</a:t>
             </a:r>
             <a:endParaRPr lang="en-US" dirty="0"/>
           </a:p>
@@ -1118,7 +1120,7 @@
           <a:p>
             <a:r>
               <a:rPr lang="en-US" dirty="0"/>
-              <a:t>La lección principal: una prueba que falla puede estar mal escrita. Antes de cambiar el código hay que entender la causa. Ninguno de estos cinco errores estaba en la aplicación.</a:t>
+              <a:t>Las pruebas crean su propia base de datos y la borran al terminar, así nunca tocan los datos reales. Las ejecutamos en Windows y en el Docker del curso, con el mismo resultado.</a:t>
             </a:r>
             <a:endParaRPr lang="en-US" dirty="0"/>
           </a:p>
@@ -1206,7 +1208,7 @@
           <a:p>
             <a:r>
               <a:rPr lang="en-US" dirty="0"/>
-              <a:t>Cerramos la Actividad 2 con la aplicación migrada, segura y probada. Las siguientes actividades ya están en el Backlog del tablero. Muchas gracias; quedamos atentos a sus preguntas.</a:t>
+              <a:t>La lección principal: una prueba que falla puede estar mal escrita. Antes de cambiar el código hay que entender la causa. Ninguno de estos cinco errores estaba en la aplicación.</a:t>
             </a:r>
             <a:endParaRPr lang="en-US" dirty="0"/>
           </a:p>
@@ -1230,6 +1232,94 @@
             <a:fld id="{F7021451-1387-4CA6-816F-3879F97B5CBC}" type="slidenum">
               <a:rPr lang="en-US"/>
               <a:t>13</a:t>
+            </a:fld>
+            <a:endParaRPr lang="en-US"/>
+          </a:p>
+        </p:txBody>
+      </p:sp>
+    </p:spTree>
+    <p:extLst>
+      <p:ext uri="{BB962C8B-B14F-4D97-AF65-F5344CB8AC3E}">
+        <p14:creationId xmlns:p14="http://schemas.microsoft.com/office/powerpoint/2010/main" val="1024086991"/>
+      </p:ext>
+    </p:extLst>
+  </p:cSld>
+  <p:clrMapOvr>
+    <a:masterClrMapping/>
+  </p:clrMapOvr>
+</p:notes>
+</file>
+
+<file path=ppt/notesSlides/notesSlide14.xml><?xml version="1.0" encoding="utf-8"?>
+<p:notes xmlns:a="http://schemas.openxmlformats.org/drawingml/2006/main" xmlns:r="http://schemas.openxmlformats.org/officeDocument/2006/relationships" xmlns:p="http://schemas.openxmlformats.org/presentationml/2006/main">
+  <p:cSld>
+    <p:spTree>
+      <p:nvGrpSpPr>
+        <p:cNvPr id="1" name=""/>
+        <p:cNvGrpSpPr/>
+        <p:nvPr/>
+      </p:nvGrpSpPr>
+      <p:grpSpPr>
+        <a:xfrm>
+          <a:off x="0" y="0"/>
+          <a:ext cx="0" cy="0"/>
+          <a:chOff x="0" y="0"/>
+          <a:chExt cx="0" cy="0"/>
+        </a:xfrm>
+      </p:grpSpPr>
+      <p:sp>
+        <p:nvSpPr>
+          <p:cNvPr id="2" name="Slide Image Placeholder 1"/>
+          <p:cNvSpPr>
+            <a:spLocks noGrp="1" noRot="1" noChangeAspect="1"/>
+          </p:cNvSpPr>
+          <p:nvPr>
+            <p:ph type="sldImg"/>
+          </p:nvPr>
+        </p:nvSpPr>
+        <p:spPr/>
+      </p:sp>
+      <p:sp>
+        <p:nvSpPr>
+          <p:cNvPr id="3" name="Notes Placeholder 2"/>
+          <p:cNvSpPr>
+            <a:spLocks noGrp="1"/>
+          </p:cNvSpPr>
+          <p:nvPr>
+            <p:ph type="body" idx="1"/>
+          </p:nvPr>
+        </p:nvSpPr>
+        <p:spPr/>
+        <p:txBody>
+          <a:bodyPr/>
+          <a:lstStyle/>
+          <a:p>
+            <a:r>
+              <a:rPr lang="en-US" dirty="0"/>
+              <a:t>Cerramos la Actividad 2 con la aplicación migrada, segura y probada. Las siguientes actividades ya están en el Backlog del tablero. Muchas gracias; quedamos atentos a sus preguntas.</a:t>
+            </a:r>
+            <a:endParaRPr lang="en-US" dirty="0"/>
+          </a:p>
+        </p:txBody>
+      </p:sp>
+      <p:sp>
+        <p:nvSpPr>
+          <p:cNvPr id="4" name="Slide Number Placeholder 3"/>
+          <p:cNvSpPr>
+            <a:spLocks noGrp="1"/>
+          </p:cNvSpPr>
+          <p:nvPr>
+            <p:ph type="sldNum" sz="quarter" idx="10"/>
+          </p:nvPr>
+        </p:nvSpPr>
+        <p:spPr/>
+        <p:txBody>
+          <a:bodyPr/>
+          <a:lstStyle/>
+          <a:p>
+            <a:fld id="{F7021451-1387-4CA6-816F-3879F97B5CBC}" type="slidenum">
+              <a:rPr lang="en-US"/>
+              <a:t>14</a:t>
             </a:fld>
             <a:endParaRPr lang="en-US"/>
           </a:p>
@@ -2763,7 +2853,7 @@
                   <a:schemeClr val="bg2"/>
                 </a:solidFill>
               </a:rPr>
-              <a:t>Tienda virtual «Manos del Oriente»: PDO, repositorios, CRUD, paginación y resistencia a la inyección SQL</a:t>
+              <a:t>Tienda virtual «Manos del Oriente»: PDO, repositorios, CRUD, paginación, resistencia a la inyección SQL e interfaz con Bootstrap 5</a:t>
             </a:r>
             <a:endParaRPr lang="en-US" sz="2000" dirty="0"/>
           </a:p>
@@ -2859,7 +2949,7 @@
                   <a:schemeClr val="bg2"/>
                 </a:solidFill>
               </a:rPr>
-              <a:t>Universidad Privada Domingo Savio · Santa Cruz de la Sierra · 13 de octubre de 2026</a:t>
+              <a:t>Universidad Privada Domingo Savio · Docente: M.Sc. Ing. Jimmy Nataniel Requena Llorentty · 14 de octubre de 2026</a:t>
             </a:r>
             <a:endParaRPr lang="en-US" sz="1400" dirty="0"/>
           </a:p>
@@ -2922,7 +3012,7 @@
                   <a:schemeClr val="tx2"/>
                 </a:solidFill>
               </a:rPr>
-              <a:t>13 ataques de inyección SQL, ninguno funcionó</a:t>
+              <a:t>Nueva interfaz: modales, avisos y paleta pastel</a:t>
             </a:r>
             <a:endParaRPr lang="en-US" sz="3000" dirty="0"/>
           </a:p>
@@ -2930,14 +3020,70 @@
       </p:sp>
       <p:sp>
         <p:nvSpPr>
-          <p:cNvPr id="3" name="Cifra 13 / 0"/>
+          <p:cNvPr id="3" name="Marco Detalle de la prenda en un modal"/>
+          <p:cNvSpPr/>
+          <p:nvPr/>
+        </p:nvSpPr>
+        <p:spPr>
+          <a:xfrm>
+            <a:off x="512064" y="1289304"/>
+            <a:ext cx="3593592" cy="2286000"/>
+          </a:xfrm>
+          <a:prstGeom prst="rect">
+            <a:avLst/>
+          </a:prstGeom>
+          <a:solidFill>
+            <a:schemeClr val="bg1"/>
+          </a:solidFill>
+          <a:ln w="12700">
+            <a:solidFill>
+              <a:srgbClr val="F8EEF0"/>
+            </a:solidFill>
+            <a:prstDash val="solid"/>
+          </a:ln>
+          <a:effectLst>
+            <a:outerShdw sx="100000" sy="100000" kx="0" ky="0" algn="bl" rotWithShape="0" blurRad="101600" dist="25400" dir="5400000">
+              <a:srgbClr val="000000">
+                <a:alpha val="18000"/>
+              </a:srgbClr>
+            </a:outerShdw>
+          </a:effectLst>
+        </p:spPr>
+      </p:sp>
+      <p:pic>
+        <p:nvPicPr>
+          <p:cNvPr id="4" name="Detalle de la prenda en un modal" descr="Detalle de la prenda en un modal">    </p:cNvPr>
+          <p:cNvPicPr>
+            <a:picLocks noChangeAspect="1"/>
+          </p:cNvPicPr>
+          <p:nvPr/>
+        </p:nvPicPr>
+        <p:blipFill>
+          <a:blip r:embed="rId1"/>
+          <a:stretch>
+            <a:fillRect/>
+          </a:stretch>
+        </p:blipFill>
+        <p:spPr>
+          <a:xfrm>
+            <a:off x="548640" y="1325880"/>
+            <a:ext cx="3520440" cy="2212848"/>
+          </a:xfrm>
+          <a:prstGeom prst="rect">
+            <a:avLst/>
+          </a:prstGeom>
+        </p:spPr>
+      </p:pic>
+      <p:sp>
+        <p:nvSpPr>
+          <p:cNvPr id="5" name="Pie Detalle de la prenda en un modal"/>
           <p:cNvSpPr txBox="1"/>
           <p:nvPr/>
         </p:nvSpPr>
         <p:spPr>
           <a:xfrm>
-            <a:off x="548640" y="1371600"/>
-            <a:ext cx="2926080" cy="868680"/>
+            <a:off x="548640" y="3639312"/>
+            <a:ext cx="3520440" cy="365760"/>
           </a:xfrm>
           <a:prstGeom prst="rect">
             <a:avLst/>
@@ -2946,21 +3092,446 @@
           <a:ln/>
         </p:spPr>
         <p:txBody>
-          <a:bodyPr wrap="square" lIns="0" tIns="0" rIns="0" bIns="0" rtlCol="0" anchor="b"/>
+          <a:bodyPr wrap="square" lIns="0" tIns="0" rIns="0" bIns="0" rtlCol="0" anchor="ctr"/>
           <a:lstStyle/>
           <a:p>
             <a:pPr indent="0" marL="0">
               <a:buNone/>
             </a:pPr>
             <a:r>
-              <a:rPr lang="en-US" sz="6000" b="1" dirty="0">
-                <a:solidFill>
-                  <a:schemeClr val="accent5"/>
+              <a:rPr lang="en-US" sz="1400" dirty="0">
+                <a:solidFill>
+                  <a:schemeClr val="accent6"/>
+                </a:solidFill>
+              </a:rPr>
+              <a:t>Detalle de la prenda en un modal</a:t>
+            </a:r>
+            <a:endParaRPr lang="en-US" sz="1400" dirty="0"/>
+          </a:p>
+        </p:txBody>
+      </p:sp>
+      <p:sp>
+        <p:nvSpPr>
+          <p:cNvPr id="6" name="Marco Confirmación antes de eliminar"/>
+          <p:cNvSpPr/>
+          <p:nvPr/>
+        </p:nvSpPr>
+        <p:spPr>
+          <a:xfrm>
+            <a:off x="4288536" y="1289304"/>
+            <a:ext cx="3593592" cy="2286000"/>
+          </a:xfrm>
+          <a:prstGeom prst="rect">
+            <a:avLst/>
+          </a:prstGeom>
+          <a:solidFill>
+            <a:schemeClr val="bg1"/>
+          </a:solidFill>
+          <a:ln w="12700">
+            <a:solidFill>
+              <a:srgbClr val="F8EEF0"/>
+            </a:solidFill>
+            <a:prstDash val="solid"/>
+          </a:ln>
+          <a:effectLst>
+            <a:outerShdw sx="100000" sy="100000" kx="0" ky="0" algn="bl" rotWithShape="0" blurRad="101600" dist="25400" dir="5400000">
+              <a:srgbClr val="000000">
+                <a:alpha val="18000"/>
+              </a:srgbClr>
+            </a:outerShdw>
+          </a:effectLst>
+        </p:spPr>
+      </p:sp>
+      <p:pic>
+        <p:nvPicPr>
+          <p:cNvPr id="7" name="Confirmación antes de eliminar" descr="Confirmación antes de eliminar">    </p:cNvPr>
+          <p:cNvPicPr>
+            <a:picLocks noChangeAspect="1"/>
+          </p:cNvPicPr>
+          <p:nvPr/>
+        </p:nvPicPr>
+        <p:blipFill>
+          <a:blip r:embed="rId2"/>
+          <a:stretch>
+            <a:fillRect/>
+          </a:stretch>
+        </p:blipFill>
+        <p:spPr>
+          <a:xfrm>
+            <a:off x="4325112" y="1325880"/>
+            <a:ext cx="3520440" cy="2212848"/>
+          </a:xfrm>
+          <a:prstGeom prst="rect">
+            <a:avLst/>
+          </a:prstGeom>
+        </p:spPr>
+      </p:pic>
+      <p:sp>
+        <p:nvSpPr>
+          <p:cNvPr id="8" name="Pie Confirmación antes de eliminar"/>
+          <p:cNvSpPr txBox="1"/>
+          <p:nvPr/>
+        </p:nvSpPr>
+        <p:spPr>
+          <a:xfrm>
+            <a:off x="4325112" y="3639312"/>
+            <a:ext cx="3520440" cy="365760"/>
+          </a:xfrm>
+          <a:prstGeom prst="rect">
+            <a:avLst/>
+          </a:prstGeom>
+          <a:noFill/>
+          <a:ln/>
+        </p:spPr>
+        <p:txBody>
+          <a:bodyPr wrap="square" lIns="0" tIns="0" rIns="0" bIns="0" rtlCol="0" anchor="ctr"/>
+          <a:lstStyle/>
+          <a:p>
+            <a:pPr indent="0" marL="0">
+              <a:buNone/>
+            </a:pPr>
+            <a:r>
+              <a:rPr lang="en-US" sz="1400" dirty="0">
+                <a:solidFill>
+                  <a:schemeClr val="accent6"/>
+                </a:solidFill>
+              </a:rPr>
+              <a:t>Confirmación antes de eliminar</a:t>
+            </a:r>
+            <a:endParaRPr lang="en-US" sz="1400" dirty="0"/>
+          </a:p>
+        </p:txBody>
+      </p:sp>
+      <p:sp>
+        <p:nvSpPr>
+          <p:cNvPr id="9" name="Marco Aviso en la esquina superior derecha"/>
+          <p:cNvSpPr/>
+          <p:nvPr/>
+        </p:nvSpPr>
+        <p:spPr>
+          <a:xfrm>
+            <a:off x="8065008" y="1289304"/>
+            <a:ext cx="3593592" cy="2286000"/>
+          </a:xfrm>
+          <a:prstGeom prst="rect">
+            <a:avLst/>
+          </a:prstGeom>
+          <a:solidFill>
+            <a:schemeClr val="bg1"/>
+          </a:solidFill>
+          <a:ln w="12700">
+            <a:solidFill>
+              <a:srgbClr val="F8EEF0"/>
+            </a:solidFill>
+            <a:prstDash val="solid"/>
+          </a:ln>
+          <a:effectLst>
+            <a:outerShdw sx="100000" sy="100000" kx="0" ky="0" algn="bl" rotWithShape="0" blurRad="101600" dist="25400" dir="5400000">
+              <a:srgbClr val="000000">
+                <a:alpha val="18000"/>
+              </a:srgbClr>
+            </a:outerShdw>
+          </a:effectLst>
+        </p:spPr>
+      </p:sp>
+      <p:pic>
+        <p:nvPicPr>
+          <p:cNvPr id="10" name="Aviso en la esquina superior derecha" descr="Aviso en la esquina superior derecha">    </p:cNvPr>
+          <p:cNvPicPr>
+            <a:picLocks noChangeAspect="1"/>
+          </p:cNvPicPr>
+          <p:nvPr/>
+        </p:nvPicPr>
+        <p:blipFill>
+          <a:blip r:embed="rId3"/>
+          <a:stretch>
+            <a:fillRect/>
+          </a:stretch>
+        </p:blipFill>
+        <p:spPr>
+          <a:xfrm>
+            <a:off x="8101584" y="1325880"/>
+            <a:ext cx="3520440" cy="2212848"/>
+          </a:xfrm>
+          <a:prstGeom prst="rect">
+            <a:avLst/>
+          </a:prstGeom>
+        </p:spPr>
+      </p:pic>
+      <p:sp>
+        <p:nvSpPr>
+          <p:cNvPr id="11" name="Pie Aviso en la esquina superior derecha"/>
+          <p:cNvSpPr txBox="1"/>
+          <p:nvPr/>
+        </p:nvSpPr>
+        <p:spPr>
+          <a:xfrm>
+            <a:off x="8101584" y="3639312"/>
+            <a:ext cx="3520440" cy="365760"/>
+          </a:xfrm>
+          <a:prstGeom prst="rect">
+            <a:avLst/>
+          </a:prstGeom>
+          <a:noFill/>
+          <a:ln/>
+        </p:spPr>
+        <p:txBody>
+          <a:bodyPr wrap="square" lIns="0" tIns="0" rIns="0" bIns="0" rtlCol="0" anchor="ctr"/>
+          <a:lstStyle/>
+          <a:p>
+            <a:pPr indent="0" marL="0">
+              <a:buNone/>
+            </a:pPr>
+            <a:r>
+              <a:rPr lang="en-US" sz="1400" dirty="0">
+                <a:solidFill>
+                  <a:schemeClr val="accent6"/>
+                </a:solidFill>
+              </a:rPr>
+              <a:t>Aviso en la esquina superior derecha</a:t>
+            </a:r>
+            <a:endParaRPr lang="en-US" sz="1400" dirty="0"/>
+          </a:p>
+        </p:txBody>
+      </p:sp>
+      <p:sp>
+        <p:nvSpPr>
+          <p:cNvPr id="12" name="Cómo funciona la interfaz (fondo)"/>
+          <p:cNvSpPr/>
+          <p:nvPr/>
+        </p:nvSpPr>
+        <p:spPr>
+          <a:xfrm>
+            <a:off x="548640" y="4206240"/>
+            <a:ext cx="11094415" cy="1463040"/>
+          </a:xfrm>
+          <a:prstGeom prst="roundRect">
+            <a:avLst>
+              <a:gd name="adj" fmla="val 7500"/>
+            </a:avLst>
+          </a:prstGeom>
+          <a:solidFill>
+            <a:schemeClr val="bg2"/>
+          </a:solidFill>
+          <a:ln/>
+        </p:spPr>
+      </p:sp>
+      <p:sp>
+        <p:nvSpPr>
+          <p:cNvPr id="13" name="Cómo funciona la interfaz (título)"/>
+          <p:cNvSpPr txBox="1"/>
+          <p:nvPr/>
+        </p:nvSpPr>
+        <p:spPr>
+          <a:xfrm>
+            <a:off x="777240" y="4370832"/>
+            <a:ext cx="10637215" cy="411480"/>
+          </a:xfrm>
+          <a:prstGeom prst="rect">
+            <a:avLst/>
+          </a:prstGeom>
+          <a:noFill/>
+          <a:ln/>
+        </p:spPr>
+        <p:txBody>
+          <a:bodyPr wrap="square" lIns="0" tIns="0" rIns="0" bIns="0" rtlCol="0" anchor="t"/>
+          <a:lstStyle/>
+          <a:p>
+            <a:pPr indent="0" marL="0">
+              <a:buNone/>
+            </a:pPr>
+            <a:r>
+              <a:rPr lang="en-US" sz="2000" b="1" dirty="0">
+                <a:solidFill>
+                  <a:schemeClr val="tx2"/>
                 </a:solidFill>
                 <a:latin typeface="Cambria" pitchFamily="34" charset="0"/>
                 <a:ea typeface="Cambria" pitchFamily="34" charset="-122"/>
                 <a:cs typeface="Cambria" pitchFamily="34" charset="-120"/>
               </a:rPr>
+              <a:t>Sin cambiar de página y sin perder la seguridad</a:t>
+            </a:r>
+            <a:endParaRPr lang="en-US" sz="2000" dirty="0"/>
+          </a:p>
+        </p:txBody>
+      </p:sp>
+      <p:sp>
+        <p:nvSpPr>
+          <p:cNvPr id="14" name="Cómo funciona la interfaz (texto)"/>
+          <p:cNvSpPr txBox="1"/>
+          <p:nvPr/>
+        </p:nvSpPr>
+        <p:spPr>
+          <a:xfrm>
+            <a:off x="777240" y="4846320"/>
+            <a:ext cx="10637215" cy="685800"/>
+          </a:xfrm>
+          <a:prstGeom prst="rect">
+            <a:avLst/>
+          </a:prstGeom>
+          <a:noFill/>
+          <a:ln/>
+        </p:spPr>
+        <p:txBody>
+          <a:bodyPr wrap="square" lIns="0" tIns="0" rIns="0" bIns="0" rtlCol="0" anchor="t"/>
+          <a:lstStyle/>
+          <a:p>
+            <a:pPr indent="0" marL="0">
+              <a:buNone/>
+            </a:pPr>
+            <a:r>
+              <a:rPr lang="en-US" sz="1700" dirty="0">
+                <a:solidFill>
+                  <a:schemeClr val="tx1"/>
+                </a:solidFill>
+              </a:rPr>
+              <a:t>Bootstrap 5 guardado en el proyecto (funciona sin internet) · ver, registrar y editar en modales · confirmación y avisos al eliminar · los modales cargan las mismas páginas PHP con X-Parcial: 1, así la validación, el token CSRF y el PRG siguen en el servidor · sin JavaScript todo funciona como antes.</a:t>
+            </a:r>
+            <a:endParaRPr lang="en-US" sz="1700" dirty="0"/>
+          </a:p>
+        </p:txBody>
+      </p:sp>
+      <p:sp>
+        <p:nvSpPr>
+          <p:cNvPr id="25" name="Slide Number Placeholder 0"/>
+          <p:cNvSpPr>
+            <a:spLocks noGrp="1"/>
+          </p:cNvSpPr>
+          <p:nvPr>
+            <p:ph type="sldNum" sz="quarter" idx="4294967295"/>
+          </p:nvPr>
+        </p:nvSpPr>
+        <p:spPr>
+          <a:xfrm>
+            <a:off x="11094415" y="6446520"/>
+            <a:ext cx="548640" cy="274320"/>
+          </a:xfrm>
+          <a:prstGeom prst="rect">
+            <a:avLst/>
+          </a:prstGeom>
+          <a:extLst>
+            <a:ext uri="{C572A759-6A51-4108-AA02-DFA0A04FC94B}">
+              <ma14:wrappingTextBoxFlag xmlns:ma14="http://schemas.microsoft.com/office/mac/drawingml/2011/main" val="0"/>
+            </a:ext>
+          </a:extLst>
+        </p:spPr>
+        <p:txBody>
+          <a:bodyPr/>
+          <a:lstStyle>
+            <a:lvl1pPr>
+              <a:defRPr sz="1000">
+                <a:solidFill>
+                  <a:schemeClr val="accent6"/>
+                </a:solidFill>
+              </a:defRPr>
+            </a:lvl1pPr>
+          </a:lstStyle>
+          <a:p>
+            <a:pPr algn="r"/>
+            <a:fld id="{F7021451-1387-4CA6-816F-3879F97B5CBC}" type="slidenum">
+              <a:rPr b="0" lang="en-US"/>
+              <a:t>10</a:t>
+            </a:fld>
+            <a:endParaRPr lang="en-US"/>
+          </a:p>
+        </p:txBody>
+      </p:sp>
+    </p:spTree>
+  </p:cSld>
+  <p:clrMapOvr>
+    <a:masterClrMapping/>
+  </p:clrMapOvr>
+</p:sld>
+</file>
+
+<file path=ppt/slides/slide11.xml><?xml version="1.0" encoding="utf-8"?>
+<p:sld xmlns:a="http://schemas.openxmlformats.org/drawingml/2006/main" xmlns:r="http://schemas.openxmlformats.org/officeDocument/2006/relationships" xmlns:p="http://schemas.openxmlformats.org/presentationml/2006/main">
+  <p:cSld name="Slide 11">
+    <p:spTree>
+      <p:nvGrpSpPr>
+        <p:cNvPr id="1" name=""/>
+        <p:cNvGrpSpPr/>
+        <p:nvPr/>
+      </p:nvGrpSpPr>
+      <p:grpSpPr>
+        <a:xfrm>
+          <a:off x="0" y="0"/>
+          <a:ext cx="0" cy="0"/>
+          <a:chOff x="0" y="0"/>
+          <a:chExt cx="0" cy="0"/>
+        </a:xfrm>
+      </p:grpSpPr>
+      <p:sp>
+        <p:nvSpPr>
+          <p:cNvPr id="2" name="Text 0"/>
+          <p:cNvSpPr/>
+          <p:nvPr>
+            <p:ph idx="100" type="title" hasCustomPrompt="1"/>
+          </p:nvPr>
+        </p:nvSpPr>
+        <p:spPr>
+          <a:xfrm>
+            <a:off x="548640" y="320040"/>
+            <a:ext cx="11094415" cy="777240"/>
+          </a:xfrm>
+          <a:prstGeom prst="rect">
+            <a:avLst/>
+          </a:prstGeom>
+          <a:noFill/>
+          <a:ln/>
+        </p:spPr>
+        <p:txBody>
+          <a:bodyPr wrap="square" lIns="0" tIns="0" rIns="0" bIns="0" rtlCol="0" anchor="ctr"/>
+          <a:lstStyle/>
+          <a:p>
+            <a:pPr indent="0" marL="0">
+              <a:buNone/>
+            </a:pPr>
+            <a:r>
+              <a:rPr lang="en-US" sz="3000" b="1" dirty="0">
+                <a:solidFill>
+                  <a:schemeClr val="tx2"/>
+                </a:solidFill>
+              </a:rPr>
+              <a:t>13 ataques de inyección SQL, ninguno funcionó</a:t>
+            </a:r>
+            <a:endParaRPr lang="en-US" sz="3000" dirty="0"/>
+          </a:p>
+        </p:txBody>
+      </p:sp>
+      <p:sp>
+        <p:nvSpPr>
+          <p:cNvPr id="3" name="Cifra 13 / 0"/>
+          <p:cNvSpPr txBox="1"/>
+          <p:nvPr/>
+        </p:nvSpPr>
+        <p:spPr>
+          <a:xfrm>
+            <a:off x="548640" y="1371600"/>
+            <a:ext cx="2926080" cy="868680"/>
+          </a:xfrm>
+          <a:prstGeom prst="rect">
+            <a:avLst/>
+          </a:prstGeom>
+          <a:noFill/>
+          <a:ln/>
+        </p:spPr>
+        <p:txBody>
+          <a:bodyPr wrap="square" lIns="0" tIns="0" rIns="0" bIns="0" rtlCol="0" anchor="b"/>
+          <a:lstStyle/>
+          <a:p>
+            <a:pPr indent="0" marL="0">
+              <a:buNone/>
+            </a:pPr>
+            <a:r>
+              <a:rPr lang="en-US" sz="6000" b="1" dirty="0">
+                <a:solidFill>
+                  <a:schemeClr val="accent5"/>
+                </a:solidFill>
+                <a:latin typeface="Cambria" pitchFamily="34" charset="0"/>
+                <a:ea typeface="Cambria" pitchFamily="34" charset="-122"/>
+                <a:cs typeface="Cambria" pitchFamily="34" charset="-120"/>
+              </a:rPr>
               <a:t>13 / 0</a:t>
             </a:r>
             <a:endParaRPr lang="en-US" sz="6000" dirty="0"/>
@@ -3005,7 +3576,7 @@
       </p:sp>
       <p:graphicFrame>
         <p:nvGraphicFramePr>
-          <p:cNvPr id="11" name="Tabla de ataques"/>
+          <p:cNvPr id="12" name="Tabla de ataques"/>
           <p:cNvGraphicFramePr>
             <a:graphicFrameLocks noGrp="1"/>
           </p:cNvGraphicFramePr>
@@ -3095,7 +3666,7 @@
                       <a:tailEnd type="none" w="med" len="med"/>
                     </a:lnB>
                     <a:solidFill>
-                      <a:srgbClr val="7A2E14"/>
+                      <a:srgbClr val="3B3542"/>
                     </a:solidFill>
                   </a:tcPr>
                 </a:tc>
@@ -3163,7 +3734,7 @@
                       <a:tailEnd type="none" w="med" len="med"/>
                     </a:lnB>
                     <a:solidFill>
-                      <a:srgbClr val="7A2E14"/>
+                      <a:srgbClr val="3B3542"/>
                     </a:solidFill>
                   </a:tcPr>
                 </a:tc>
@@ -3231,7 +3802,7 @@
                       <a:tailEnd type="none" w="med" len="med"/>
                     </a:lnB>
                     <a:solidFill>
-                      <a:srgbClr val="7A2E14"/>
+                      <a:srgbClr val="3B3542"/>
                     </a:solidFill>
                   </a:tcPr>
                 </a:tc>
@@ -3248,7 +3819,7 @@
                       <a:r>
                         <a:rPr lang="en-US" sz="1500" dirty="0">
                           <a:solidFill>
-                            <a:srgbClr val="2B1A12"/>
+                            <a:srgbClr val="2D2A32"/>
                           </a:solidFill>
                           <a:latin typeface="Calibri" pitchFamily="34" charset="0"/>
                           <a:ea typeface="Calibri" pitchFamily="34" charset="-122"/>
@@ -3313,7 +3884,7 @@
                       <a:r>
                         <a:rPr lang="en-US" sz="1500" dirty="0">
                           <a:solidFill>
-                            <a:srgbClr val="2B1A12"/>
+                            <a:srgbClr val="2D2A32"/>
                           </a:solidFill>
                           <a:latin typeface="Calibri" pitchFamily="34" charset="0"/>
                           <a:ea typeface="Calibri" pitchFamily="34" charset="-122"/>
@@ -3378,7 +3949,7 @@
                       <a:r>
                         <a:rPr lang="en-US" sz="1500" dirty="0">
                           <a:solidFill>
-                            <a:srgbClr val="2B1A12"/>
+                            <a:srgbClr val="2D2A32"/>
                           </a:solidFill>
                           <a:latin typeface="Calibri" pitchFamily="34" charset="0"/>
                           <a:ea typeface="Calibri" pitchFamily="34" charset="-122"/>
@@ -3445,7 +4016,7 @@
                       <a:r>
                         <a:rPr lang="en-US" sz="1500" dirty="0">
                           <a:solidFill>
-                            <a:srgbClr val="2B1A12"/>
+                            <a:srgbClr val="2D2A32"/>
                           </a:solidFill>
                           <a:latin typeface="Calibri" pitchFamily="34" charset="0"/>
                           <a:ea typeface="Calibri" pitchFamily="34" charset="-122"/>
@@ -3510,7 +4081,7 @@
                       <a:r>
                         <a:rPr lang="en-US" sz="1500" dirty="0">
                           <a:solidFill>
-                            <a:srgbClr val="2B1A12"/>
+                            <a:srgbClr val="2D2A32"/>
                           </a:solidFill>
                           <a:latin typeface="Calibri" pitchFamily="34" charset="0"/>
                           <a:ea typeface="Calibri" pitchFamily="34" charset="-122"/>
@@ -3575,7 +4146,7 @@
                       <a:r>
                         <a:rPr lang="en-US" sz="1500" dirty="0">
                           <a:solidFill>
-                            <a:srgbClr val="2B1A12"/>
+                            <a:srgbClr val="2D2A32"/>
                           </a:solidFill>
                           <a:latin typeface="Calibri" pitchFamily="34" charset="0"/>
                           <a:ea typeface="Calibri" pitchFamily="34" charset="-122"/>
@@ -3642,7 +4213,7 @@
                       <a:r>
                         <a:rPr lang="en-US" sz="1500" dirty="0">
                           <a:solidFill>
-                            <a:srgbClr val="2B1A12"/>
+                            <a:srgbClr val="2D2A32"/>
                           </a:solidFill>
                           <a:latin typeface="Calibri" pitchFamily="34" charset="0"/>
                           <a:ea typeface="Calibri" pitchFamily="34" charset="-122"/>
@@ -3707,7 +4278,7 @@
                       <a:r>
                         <a:rPr lang="en-US" sz="1500" dirty="0">
                           <a:solidFill>
-                            <a:srgbClr val="2B1A12"/>
+                            <a:srgbClr val="2D2A32"/>
                           </a:solidFill>
                           <a:latin typeface="Calibri" pitchFamily="34" charset="0"/>
                           <a:ea typeface="Calibri" pitchFamily="34" charset="-122"/>
@@ -3772,7 +4343,7 @@
                       <a:r>
                         <a:rPr lang="en-US" sz="1500" dirty="0">
                           <a:solidFill>
-                            <a:srgbClr val="2B1A12"/>
+                            <a:srgbClr val="2D2A32"/>
                           </a:solidFill>
                           <a:latin typeface="Calibri" pitchFamily="34" charset="0"/>
                           <a:ea typeface="Calibri" pitchFamily="34" charset="-122"/>
@@ -3839,7 +4410,7 @@
                       <a:r>
                         <a:rPr lang="en-US" sz="1500" dirty="0">
                           <a:solidFill>
-                            <a:srgbClr val="2B1A12"/>
+                            <a:srgbClr val="2D2A32"/>
                           </a:solidFill>
                           <a:latin typeface="Calibri" pitchFamily="34" charset="0"/>
                           <a:ea typeface="Calibri" pitchFamily="34" charset="-122"/>
@@ -3904,7 +4475,7 @@
                       <a:r>
                         <a:rPr lang="en-US" sz="1500" dirty="0">
                           <a:solidFill>
-                            <a:srgbClr val="2B1A12"/>
+                            <a:srgbClr val="2D2A32"/>
                           </a:solidFill>
                           <a:latin typeface="Calibri" pitchFamily="34" charset="0"/>
                           <a:ea typeface="Calibri" pitchFamily="34" charset="-122"/>
@@ -3969,7 +4540,7 @@
                       <a:r>
                         <a:rPr lang="en-US" sz="1500" dirty="0">
                           <a:solidFill>
-                            <a:srgbClr val="2B1A12"/>
+                            <a:srgbClr val="2D2A32"/>
                           </a:solidFill>
                           <a:latin typeface="Calibri" pitchFamily="34" charset="0"/>
                           <a:ea typeface="Calibri" pitchFamily="34" charset="-122"/>
@@ -4036,7 +4607,7 @@
                       <a:r>
                         <a:rPr lang="en-US" sz="1500" dirty="0">
                           <a:solidFill>
-                            <a:srgbClr val="2B1A12"/>
+                            <a:srgbClr val="2D2A32"/>
                           </a:solidFill>
                           <a:latin typeface="Calibri" pitchFamily="34" charset="0"/>
                           <a:ea typeface="Calibri" pitchFamily="34" charset="-122"/>
@@ -4101,7 +4672,7 @@
                       <a:r>
                         <a:rPr lang="en-US" sz="1500" dirty="0">
                           <a:solidFill>
-                            <a:srgbClr val="2B1A12"/>
+                            <a:srgbClr val="2D2A32"/>
                           </a:solidFill>
                           <a:latin typeface="Calibri" pitchFamily="34" charset="0"/>
                           <a:ea typeface="Calibri" pitchFamily="34" charset="-122"/>
@@ -4166,7 +4737,7 @@
                       <a:r>
                         <a:rPr lang="en-US" sz="1500" dirty="0">
                           <a:solidFill>
-                            <a:srgbClr val="2B1A12"/>
+                            <a:srgbClr val="2D2A32"/>
                           </a:solidFill>
                           <a:latin typeface="Calibri" pitchFamily="34" charset="0"/>
                           <a:ea typeface="Calibri" pitchFamily="34" charset="-122"/>
@@ -4361,352 +4932,6 @@
             <a:pPr algn="r"/>
             <a:fld id="{F7021451-1387-4CA6-816F-3879F97B5CBC}" type="slidenum">
               <a:rPr b="0" lang="en-US"/>
-              <a:t>10</a:t>
-            </a:fld>
-            <a:endParaRPr lang="en-US"/>
-          </a:p>
-        </p:txBody>
-      </p:sp>
-    </p:spTree>
-  </p:cSld>
-  <p:clrMapOvr>
-    <a:masterClrMapping/>
-  </p:clrMapOvr>
-</p:sld>
-</file>
-
-<file path=ppt/slides/slide11.xml><?xml version="1.0" encoding="utf-8"?>
-<p:sld xmlns:a="http://schemas.openxmlformats.org/drawingml/2006/main" xmlns:r="http://schemas.openxmlformats.org/officeDocument/2006/relationships" xmlns:p="http://schemas.openxmlformats.org/presentationml/2006/main">
-  <p:cSld name="Slide 11">
-    <p:spTree>
-      <p:nvGrpSpPr>
-        <p:cNvPr id="1" name=""/>
-        <p:cNvGrpSpPr/>
-        <p:nvPr/>
-      </p:nvGrpSpPr>
-      <p:grpSpPr>
-        <a:xfrm>
-          <a:off x="0" y="0"/>
-          <a:ext cx="0" cy="0"/>
-          <a:chOff x="0" y="0"/>
-          <a:chExt cx="0" cy="0"/>
-        </a:xfrm>
-      </p:grpSpPr>
-      <p:sp>
-        <p:nvSpPr>
-          <p:cNvPr id="2" name="Text 0"/>
-          <p:cNvSpPr/>
-          <p:nvPr>
-            <p:ph idx="100" type="title" hasCustomPrompt="1"/>
-          </p:nvPr>
-        </p:nvSpPr>
-        <p:spPr>
-          <a:xfrm>
-            <a:off x="548640" y="320040"/>
-            <a:ext cx="11094415" cy="777240"/>
-          </a:xfrm>
-          <a:prstGeom prst="rect">
-            <a:avLst/>
-          </a:prstGeom>
-          <a:noFill/>
-          <a:ln/>
-        </p:spPr>
-        <p:txBody>
-          <a:bodyPr wrap="square" lIns="0" tIns="0" rIns="0" bIns="0" rtlCol="0" anchor="ctr"/>
-          <a:lstStyle/>
-          <a:p>
-            <a:pPr indent="0" marL="0">
-              <a:buNone/>
-            </a:pPr>
-            <a:r>
-              <a:rPr lang="en-US" sz="3000" b="1" dirty="0">
-                <a:solidFill>
-                  <a:schemeClr val="tx2"/>
-                </a:solidFill>
-              </a:rPr>
-              <a:t>57 de 57 pruebas en dos entornos distintos</a:t>
-            </a:r>
-            <a:endParaRPr lang="en-US" sz="3000" dirty="0"/>
-          </a:p>
-        </p:txBody>
-      </p:sp>
-      <p:graphicFrame>
-        <p:nvGraphicFramePr>
-          <p:cNvPr id="3" name="Gráfico de pruebas" descr=""/>
-          <p:cNvGraphicFramePr/>
-          <p:nvPr/>
-        </p:nvGraphicFramePr>
-        <p:xfrm>
-          <a:off x="548640" y="1280160"/>
-          <a:ext cx="6766560" cy="4572000"/>
-        </p:xfrm>
-        <a:graphic xmlns:a="http://schemas.openxmlformats.org/drawingml/2006/main">
-          <a:graphicData uri="http://schemas.openxmlformats.org/drawingml/2006/chart">
-            <c:chart xmlns:c="http://schemas.openxmlformats.org/drawingml/2006/chart" r:id="rId1"/>
-          </a:graphicData>
-        </a:graphic>
-      </p:graphicFrame>
-      <p:sp>
-        <p:nvSpPr>
-          <p:cNvPr id="4" name="Entorno Windows"/>
-          <p:cNvSpPr/>
-          <p:nvPr/>
-        </p:nvSpPr>
-        <p:spPr>
-          <a:xfrm>
-            <a:off x="7680960" y="1371600"/>
-            <a:ext cx="3959352" cy="2011680"/>
-          </a:xfrm>
-          <a:prstGeom prst="roundRect">
-            <a:avLst>
-              <a:gd name="adj" fmla="val 5455"/>
-            </a:avLst>
-          </a:prstGeom>
-          <a:solidFill>
-            <a:schemeClr val="bg2"/>
-          </a:solidFill>
-          <a:ln/>
-        </p:spPr>
-      </p:sp>
-      <p:sp>
-        <p:nvSpPr>
-          <p:cNvPr id="5" name="Resultado Windows"/>
-          <p:cNvSpPr txBox="1"/>
-          <p:nvPr/>
-        </p:nvSpPr>
-        <p:spPr>
-          <a:xfrm>
-            <a:off x="7909560" y="1554480"/>
-            <a:ext cx="3566160" cy="868680"/>
-          </a:xfrm>
-          <a:prstGeom prst="rect">
-            <a:avLst/>
-          </a:prstGeom>
-          <a:noFill/>
-          <a:ln/>
-        </p:spPr>
-        <p:txBody>
-          <a:bodyPr wrap="square" lIns="0" tIns="0" rIns="0" bIns="0" rtlCol="0" anchor="ctr"/>
-          <a:lstStyle/>
-          <a:p>
-            <a:pPr indent="0" marL="0">
-              <a:buNone/>
-            </a:pPr>
-            <a:r>
-              <a:rPr lang="en-US" sz="4800" b="1" dirty="0">
-                <a:solidFill>
-                  <a:schemeClr val="accent2"/>
-                </a:solidFill>
-                <a:latin typeface="Cambria" pitchFamily="34" charset="0"/>
-                <a:ea typeface="Cambria" pitchFamily="34" charset="-122"/>
-                <a:cs typeface="Cambria" pitchFamily="34" charset="-120"/>
-              </a:rPr>
-              <a:t>57/57</a:t>
-            </a:r>
-            <a:endParaRPr lang="en-US" sz="4800" dirty="0"/>
-          </a:p>
-        </p:txBody>
-      </p:sp>
-      <p:sp>
-        <p:nvSpPr>
-          <p:cNvPr id="6" name="Entorno texto Windows"/>
-          <p:cNvSpPr txBox="1"/>
-          <p:nvPr/>
-        </p:nvSpPr>
-        <p:spPr>
-          <a:xfrm>
-            <a:off x="7909560" y="2468880"/>
-            <a:ext cx="3566160" cy="777240"/>
-          </a:xfrm>
-          <a:prstGeom prst="rect">
-            <a:avLst/>
-          </a:prstGeom>
-          <a:noFill/>
-          <a:ln/>
-        </p:spPr>
-        <p:txBody>
-          <a:bodyPr wrap="square" lIns="0" tIns="0" rIns="0" bIns="0" rtlCol="0" anchor="t"/>
-          <a:lstStyle/>
-          <a:p>
-            <a:pPr indent="0" marL="0">
-              <a:buNone/>
-            </a:pPr>
-            <a:r>
-              <a:rPr lang="en-US" sz="1600" b="1" dirty="0">
-                <a:solidFill>
-                  <a:schemeClr val="tx2"/>
-                </a:solidFill>
-              </a:rPr>
-              <a:t>Windows</a:t>
-            </a:r>
-            <a:endParaRPr lang="en-US" sz="1600" dirty="0"/>
-          </a:p>
-          <a:p>
-            <a:pPr indent="0" marL="0">
-              <a:buNone/>
-            </a:pPr>
-            <a:r>
-              <a:rPr lang="en-US" sz="1600" dirty="0">
-                <a:solidFill>
-                  <a:schemeClr val="tx1"/>
-                </a:solidFill>
-              </a:rPr>
-              <a:t>PHP 8.4 + MariaDB 10.4 (XAMPP)</a:t>
-            </a:r>
-            <a:endParaRPr lang="en-US" sz="1600" dirty="0"/>
-          </a:p>
-        </p:txBody>
-      </p:sp>
-      <p:sp>
-        <p:nvSpPr>
-          <p:cNvPr id="7" name="Entorno Docker del curso"/>
-          <p:cNvSpPr/>
-          <p:nvPr/>
-        </p:nvSpPr>
-        <p:spPr>
-          <a:xfrm>
-            <a:off x="7680960" y="3611880"/>
-            <a:ext cx="3959352" cy="2011680"/>
-          </a:xfrm>
-          <a:prstGeom prst="roundRect">
-            <a:avLst>
-              <a:gd name="adj" fmla="val 5455"/>
-            </a:avLst>
-          </a:prstGeom>
-          <a:solidFill>
-            <a:schemeClr val="bg2"/>
-          </a:solidFill>
-          <a:ln/>
-        </p:spPr>
-      </p:sp>
-      <p:sp>
-        <p:nvSpPr>
-          <p:cNvPr id="8" name="Resultado Docker del curso"/>
-          <p:cNvSpPr txBox="1"/>
-          <p:nvPr/>
-        </p:nvSpPr>
-        <p:spPr>
-          <a:xfrm>
-            <a:off x="7909560" y="3794760"/>
-            <a:ext cx="3566160" cy="868680"/>
-          </a:xfrm>
-          <a:prstGeom prst="rect">
-            <a:avLst/>
-          </a:prstGeom>
-          <a:noFill/>
-          <a:ln/>
-        </p:spPr>
-        <p:txBody>
-          <a:bodyPr wrap="square" lIns="0" tIns="0" rIns="0" bIns="0" rtlCol="0" anchor="ctr"/>
-          <a:lstStyle/>
-          <a:p>
-            <a:pPr indent="0" marL="0">
-              <a:buNone/>
-            </a:pPr>
-            <a:r>
-              <a:rPr lang="en-US" sz="4800" b="1" dirty="0">
-                <a:solidFill>
-                  <a:schemeClr val="accent2"/>
-                </a:solidFill>
-                <a:latin typeface="Cambria" pitchFamily="34" charset="0"/>
-                <a:ea typeface="Cambria" pitchFamily="34" charset="-122"/>
-                <a:cs typeface="Cambria" pitchFamily="34" charset="-120"/>
-              </a:rPr>
-              <a:t>57/57</a:t>
-            </a:r>
-            <a:endParaRPr lang="en-US" sz="4800" dirty="0"/>
-          </a:p>
-        </p:txBody>
-      </p:sp>
-      <p:sp>
-        <p:nvSpPr>
-          <p:cNvPr id="9" name="Entorno texto Docker del curso"/>
-          <p:cNvSpPr txBox="1"/>
-          <p:nvPr/>
-        </p:nvSpPr>
-        <p:spPr>
-          <a:xfrm>
-            <a:off x="7909560" y="4709160"/>
-            <a:ext cx="3566160" cy="777240"/>
-          </a:xfrm>
-          <a:prstGeom prst="rect">
-            <a:avLst/>
-          </a:prstGeom>
-          <a:noFill/>
-          <a:ln/>
-        </p:spPr>
-        <p:txBody>
-          <a:bodyPr wrap="square" lIns="0" tIns="0" rIns="0" bIns="0" rtlCol="0" anchor="t"/>
-          <a:lstStyle/>
-          <a:p>
-            <a:pPr indent="0" marL="0">
-              <a:buNone/>
-            </a:pPr>
-            <a:r>
-              <a:rPr lang="en-US" sz="1600" b="1" dirty="0">
-                <a:solidFill>
-                  <a:schemeClr val="tx2"/>
-                </a:solidFill>
-              </a:rPr>
-              <a:t>Docker del curso</a:t>
-            </a:r>
-            <a:endParaRPr lang="en-US" sz="1600" dirty="0"/>
-          </a:p>
-          <a:p>
-            <a:pPr indent="0" marL="0">
-              <a:buNone/>
-            </a:pPr>
-            <a:r>
-              <a:rPr lang="en-US" sz="1600" dirty="0">
-                <a:solidFill>
-                  <a:schemeClr val="tx1"/>
-                </a:solidFill>
-              </a:rPr>
-              <a:t>PHP 8.3 + MySQL 8.4</a:t>
-            </a:r>
-            <a:endParaRPr lang="en-US" sz="1600" dirty="0"/>
-          </a:p>
-        </p:txBody>
-      </p:sp>
-      <p:sp>
-        <p:nvSpPr>
-          <p:cNvPr id="25" name="Slide Number Placeholder 0"/>
-          <p:cNvSpPr>
-            <a:spLocks noGrp="1"/>
-          </p:cNvSpPr>
-          <p:nvPr>
-            <p:ph type="sldNum" sz="quarter" idx="4294967295"/>
-          </p:nvPr>
-        </p:nvSpPr>
-        <p:spPr>
-          <a:xfrm>
-            <a:off x="11094415" y="6446520"/>
-            <a:ext cx="548640" cy="274320"/>
-          </a:xfrm>
-          <a:prstGeom prst="rect">
-            <a:avLst/>
-          </a:prstGeom>
-          <a:extLst>
-            <a:ext uri="{C572A759-6A51-4108-AA02-DFA0A04FC94B}">
-              <ma14:wrappingTextBoxFlag xmlns:ma14="http://schemas.microsoft.com/office/mac/drawingml/2011/main" val="0"/>
-            </a:ext>
-          </a:extLst>
-        </p:spPr>
-        <p:txBody>
-          <a:bodyPr/>
-          <a:lstStyle>
-            <a:lvl1pPr>
-              <a:defRPr sz="1000">
-                <a:solidFill>
-                  <a:schemeClr val="accent6"/>
-                </a:solidFill>
-              </a:defRPr>
-            </a:lvl1pPr>
-          </a:lstStyle>
-          <a:p>
-            <a:pPr algn="r"/>
-            <a:fld id="{F7021451-1387-4CA6-816F-3879F97B5CBC}" type="slidenum">
-              <a:rPr b="0" lang="en-US"/>
               <a:t>11</a:t>
             </a:fld>
             <a:endParaRPr lang="en-US"/>
@@ -4770,22 +4995,60 @@
                   <a:schemeClr val="tx2"/>
                 </a:solidFill>
               </a:rPr>
-              <a:t>Lo que nos enseñó trabajar con inteligencia artificial</a:t>
+              <a:t>57 de 57 pruebas en dos entornos distintos</a:t>
             </a:r>
             <a:endParaRPr lang="en-US" sz="3000" dirty="0"/>
           </a:p>
         </p:txBody>
       </p:sp>
-      <p:sp>
-        <p:nvSpPr>
-          <p:cNvPr id="3" name="Introducción IA"/>
+      <p:graphicFrame>
+        <p:nvGraphicFramePr>
+          <p:cNvPr id="3" name="Gráfico de pruebas" descr=""/>
+          <p:cNvGraphicFramePr/>
+          <p:nvPr/>
+        </p:nvGraphicFramePr>
+        <p:xfrm>
+          <a:off x="548640" y="1280160"/>
+          <a:ext cx="6766560" cy="4572000"/>
+        </p:xfrm>
+        <a:graphic xmlns:a="http://schemas.openxmlformats.org/drawingml/2006/main">
+          <a:graphicData uri="http://schemas.openxmlformats.org/drawingml/2006/chart">
+            <c:chart xmlns:c="http://schemas.openxmlformats.org/drawingml/2006/chart" r:id="rId1"/>
+          </a:graphicData>
+        </a:graphic>
+      </p:graphicFrame>
+      <p:sp>
+        <p:nvSpPr>
+          <p:cNvPr id="4" name="Entorno Windows"/>
+          <p:cNvSpPr/>
+          <p:nvPr/>
+        </p:nvSpPr>
+        <p:spPr>
+          <a:xfrm>
+            <a:off x="7680960" y="1371600"/>
+            <a:ext cx="3959352" cy="2011680"/>
+          </a:xfrm>
+          <a:prstGeom prst="roundRect">
+            <a:avLst>
+              <a:gd name="adj" fmla="val 5455"/>
+            </a:avLst>
+          </a:prstGeom>
+          <a:solidFill>
+            <a:schemeClr val="bg2"/>
+          </a:solidFill>
+          <a:ln/>
+        </p:spPr>
+      </p:sp>
+      <p:sp>
+        <p:nvSpPr>
+          <p:cNvPr id="5" name="Resultado Windows"/>
           <p:cNvSpPr txBox="1"/>
           <p:nvPr/>
         </p:nvSpPr>
         <p:spPr>
           <a:xfrm>
-            <a:off x="548640" y="1280160"/>
-            <a:ext cx="11094415" cy="457200"/>
+            <a:off x="7909560" y="1554480"/>
+            <a:ext cx="3566160" cy="868680"/>
           </a:xfrm>
           <a:prstGeom prst="rect">
             <a:avLst/>
@@ -4801,47 +5064,102 @@
               <a:buNone/>
             </a:pPr>
             <a:r>
-              <a:rPr lang="en-US" sz="1700" dirty="0">
+              <a:rPr lang="en-US" sz="4800" b="1" dirty="0">
+                <a:solidFill>
+                  <a:schemeClr val="accent2"/>
+                </a:solidFill>
+                <a:latin typeface="Cambria" pitchFamily="34" charset="0"/>
+                <a:ea typeface="Cambria" pitchFamily="34" charset="-122"/>
+                <a:cs typeface="Cambria" pitchFamily="34" charset="-120"/>
+              </a:rPr>
+              <a:t>57/57</a:t>
+            </a:r>
+            <a:endParaRPr lang="en-US" sz="4800" dirty="0"/>
+          </a:p>
+        </p:txBody>
+      </p:sp>
+      <p:sp>
+        <p:nvSpPr>
+          <p:cNvPr id="6" name="Entorno texto Windows"/>
+          <p:cNvSpPr txBox="1"/>
+          <p:nvPr/>
+        </p:nvSpPr>
+        <p:spPr>
+          <a:xfrm>
+            <a:off x="7909560" y="2468880"/>
+            <a:ext cx="3566160" cy="777240"/>
+          </a:xfrm>
+          <a:prstGeom prst="rect">
+            <a:avLst/>
+          </a:prstGeom>
+          <a:noFill/>
+          <a:ln/>
+        </p:spPr>
+        <p:txBody>
+          <a:bodyPr wrap="square" lIns="0" tIns="0" rIns="0" bIns="0" rtlCol="0" anchor="t"/>
+          <a:lstStyle/>
+          <a:p>
+            <a:pPr indent="0" marL="0">
+              <a:buNone/>
+            </a:pPr>
+            <a:r>
+              <a:rPr lang="en-US" sz="1600" b="1" dirty="0">
+                <a:solidFill>
+                  <a:schemeClr val="tx2"/>
+                </a:solidFill>
+              </a:rPr>
+              <a:t>Windows</a:t>
+            </a:r>
+            <a:endParaRPr lang="en-US" sz="1600" dirty="0"/>
+          </a:p>
+          <a:p>
+            <a:pPr indent="0" marL="0">
+              <a:buNone/>
+            </a:pPr>
+            <a:r>
+              <a:rPr lang="en-US" sz="1600" dirty="0">
                 <a:solidFill>
                   <a:schemeClr val="tx1"/>
                 </a:solidFill>
               </a:rPr>
-              <a:t>La IA propone, el equipo decide. Cinco propuestas tenían errores, y las pruebas los detectaron:</a:t>
-            </a:r>
-            <a:endParaRPr lang="en-US" sz="1700" dirty="0"/>
-          </a:p>
-        </p:txBody>
-      </p:sp>
-      <p:sp>
-        <p:nvSpPr>
-          <p:cNvPr id="4" name="Insignia 1"/>
+              <a:t>PHP 8.4 + MariaDB 10.4 (XAMPP)</a:t>
+            </a:r>
+            <a:endParaRPr lang="en-US" sz="1600" dirty="0"/>
+          </a:p>
+        </p:txBody>
+      </p:sp>
+      <p:sp>
+        <p:nvSpPr>
+          <p:cNvPr id="7" name="Entorno Docker del curso"/>
           <p:cNvSpPr/>
           <p:nvPr/>
         </p:nvSpPr>
         <p:spPr>
           <a:xfrm>
-            <a:off x="548640" y="2029968"/>
-            <a:ext cx="502920" cy="502920"/>
-          </a:xfrm>
-          <a:prstGeom prst="ellipse">
-            <a:avLst/>
+            <a:off x="7680960" y="3611880"/>
+            <a:ext cx="3959352" cy="2011680"/>
+          </a:xfrm>
+          <a:prstGeom prst="roundRect">
+            <a:avLst>
+              <a:gd name="adj" fmla="val 5455"/>
+            </a:avLst>
           </a:prstGeom>
           <a:solidFill>
-            <a:schemeClr val="accent3"/>
+            <a:schemeClr val="bg2"/>
           </a:solidFill>
           <a:ln/>
         </p:spPr>
       </p:sp>
       <p:sp>
         <p:nvSpPr>
-          <p:cNvPr id="5" name="Insignia texto 1"/>
+          <p:cNvPr id="8" name="Resultado Docker del curso"/>
           <p:cNvSpPr txBox="1"/>
           <p:nvPr/>
         </p:nvSpPr>
         <p:spPr>
           <a:xfrm>
-            <a:off x="548640" y="2029968"/>
-            <a:ext cx="502920" cy="502920"/>
+            <a:off x="7909560" y="3794760"/>
+            <a:ext cx="3566160" cy="868680"/>
           </a:xfrm>
           <a:prstGeom prst="rect">
             <a:avLst/>
@@ -4853,492 +5171,71 @@
           <a:bodyPr wrap="square" lIns="0" tIns="0" rIns="0" bIns="0" rtlCol="0" anchor="ctr"/>
           <a:lstStyle/>
           <a:p>
-            <a:pPr algn="ctr" indent="0" marL="0">
+            <a:pPr indent="0" marL="0">
+              <a:buNone/>
+            </a:pPr>
+            <a:r>
+              <a:rPr lang="en-US" sz="4800" b="1" dirty="0">
+                <a:solidFill>
+                  <a:schemeClr val="accent2"/>
+                </a:solidFill>
+                <a:latin typeface="Cambria" pitchFamily="34" charset="0"/>
+                <a:ea typeface="Cambria" pitchFamily="34" charset="-122"/>
+                <a:cs typeface="Cambria" pitchFamily="34" charset="-120"/>
+              </a:rPr>
+              <a:t>57/57</a:t>
+            </a:r>
+            <a:endParaRPr lang="en-US" sz="4800" dirty="0"/>
+          </a:p>
+        </p:txBody>
+      </p:sp>
+      <p:sp>
+        <p:nvSpPr>
+          <p:cNvPr id="9" name="Entorno texto Docker del curso"/>
+          <p:cNvSpPr txBox="1"/>
+          <p:nvPr/>
+        </p:nvSpPr>
+        <p:spPr>
+          <a:xfrm>
+            <a:off x="7909560" y="4709160"/>
+            <a:ext cx="3566160" cy="777240"/>
+          </a:xfrm>
+          <a:prstGeom prst="rect">
+            <a:avLst/>
+          </a:prstGeom>
+          <a:noFill/>
+          <a:ln/>
+        </p:spPr>
+        <p:txBody>
+          <a:bodyPr wrap="square" lIns="0" tIns="0" rIns="0" bIns="0" rtlCol="0" anchor="t"/>
+          <a:lstStyle/>
+          <a:p>
+            <a:pPr indent="0" marL="0">
               <a:buNone/>
             </a:pPr>
             <a:r>
               <a:rPr lang="en-US" sz="1600" b="1" dirty="0">
                 <a:solidFill>
-                  <a:schemeClr val="bg1"/>
-                </a:solidFill>
-              </a:rPr>
-              <a:t>1</a:t>
+                  <a:schemeClr val="tx2"/>
+                </a:solidFill>
+              </a:rPr>
+              <a:t>Docker del curso</a:t>
             </a:r>
             <a:endParaRPr lang="en-US" sz="1600" dirty="0"/>
           </a:p>
-        </p:txBody>
-      </p:sp>
-      <p:sp>
-        <p:nvSpPr>
-          <p:cNvPr id="6" name="Fila 1"/>
-          <p:cNvSpPr txBox="1"/>
-          <p:nvPr/>
-        </p:nvSpPr>
-        <p:spPr>
-          <a:xfrm>
-            <a:off x="1234440" y="2011680"/>
-            <a:ext cx="4709160" cy="777240"/>
-          </a:xfrm>
-          <a:prstGeom prst="rect">
-            <a:avLst/>
-          </a:prstGeom>
-          <a:noFill/>
-          <a:ln/>
-        </p:spPr>
-        <p:txBody>
-          <a:bodyPr wrap="square" lIns="0" tIns="0" rIns="0" bIns="0" rtlCol="0" anchor="t"/>
-          <a:lstStyle/>
           <a:p>
             <a:pPr indent="0" marL="0">
               <a:buNone/>
             </a:pPr>
             <a:r>
-              <a:rPr lang="en-US" sz="1700" b="1" dirty="0">
+              <a:rPr lang="en-US" sz="1600" dirty="0">
                 <a:solidFill>
                   <a:schemeClr val="tx1"/>
                 </a:solidFill>
               </a:rPr>
-              <a:t>Contó 5 claves foráneas</a:t>
-            </a:r>
-            <a:endParaRPr lang="en-US" sz="1700" dirty="0"/>
-          </a:p>
-          <a:p>
-            <a:pPr indent="0" marL="0">
-              <a:buNone/>
-            </a:pPr>
-            <a:r>
-              <a:rPr lang="en-US" sz="1700" dirty="0">
-                <a:solidFill>
-                  <a:schemeClr val="accent6"/>
-                </a:solidFill>
-              </a:rPr>
-              <a:t>El esquema tiene 4.</a:t>
-            </a:r>
-            <a:endParaRPr lang="en-US" sz="1700" dirty="0"/>
-          </a:p>
-        </p:txBody>
-      </p:sp>
-      <p:sp>
-        <p:nvSpPr>
-          <p:cNvPr id="7" name="Insignia 2"/>
-          <p:cNvSpPr/>
-          <p:nvPr/>
-        </p:nvSpPr>
-        <p:spPr>
-          <a:xfrm>
-            <a:off x="548640" y="3218688"/>
-            <a:ext cx="502920" cy="502920"/>
-          </a:xfrm>
-          <a:prstGeom prst="ellipse">
-            <a:avLst/>
-          </a:prstGeom>
-          <a:solidFill>
-            <a:schemeClr val="accent3"/>
-          </a:solidFill>
-          <a:ln/>
-        </p:spPr>
-      </p:sp>
-      <p:sp>
-        <p:nvSpPr>
-          <p:cNvPr id="8" name="Insignia texto 2"/>
-          <p:cNvSpPr txBox="1"/>
-          <p:nvPr/>
-        </p:nvSpPr>
-        <p:spPr>
-          <a:xfrm>
-            <a:off x="548640" y="3218688"/>
-            <a:ext cx="502920" cy="502920"/>
-          </a:xfrm>
-          <a:prstGeom prst="rect">
-            <a:avLst/>
-          </a:prstGeom>
-          <a:noFill/>
-          <a:ln/>
-        </p:spPr>
-        <p:txBody>
-          <a:bodyPr wrap="square" lIns="0" tIns="0" rIns="0" bIns="0" rtlCol="0" anchor="ctr"/>
-          <a:lstStyle/>
-          <a:p>
-            <a:pPr algn="ctr" indent="0" marL="0">
-              <a:buNone/>
-            </a:pPr>
-            <a:r>
-              <a:rPr lang="en-US" sz="1600" b="1" dirty="0">
-                <a:solidFill>
-                  <a:schemeClr val="bg1"/>
-                </a:solidFill>
-              </a:rPr>
-              <a:t>2</a:t>
+              <a:t>PHP 8.3 + MySQL 8.4</a:t>
             </a:r>
             <a:endParaRPr lang="en-US" sz="1600" dirty="0"/>
-          </a:p>
-        </p:txBody>
-      </p:sp>
-      <p:sp>
-        <p:nvSpPr>
-          <p:cNvPr id="9" name="Fila 2"/>
-          <p:cNvSpPr txBox="1"/>
-          <p:nvPr/>
-        </p:nvSpPr>
-        <p:spPr>
-          <a:xfrm>
-            <a:off x="1234440" y="3200400"/>
-            <a:ext cx="4709160" cy="777240"/>
-          </a:xfrm>
-          <a:prstGeom prst="rect">
-            <a:avLst/>
-          </a:prstGeom>
-          <a:noFill/>
-          <a:ln/>
-        </p:spPr>
-        <p:txBody>
-          <a:bodyPr wrap="square" lIns="0" tIns="0" rIns="0" bIns="0" rtlCol="0" anchor="t"/>
-          <a:lstStyle/>
-          <a:p>
-            <a:pPr indent="0" marL="0">
-              <a:buNone/>
-            </a:pPr>
-            <a:r>
-              <a:rPr lang="en-US" sz="1700" b="1" dirty="0">
-                <a:solidFill>
-                  <a:schemeClr val="tx1"/>
-                </a:solidFill>
-              </a:rPr>
-              <a:t>Supuso que la prenda nueva tendría id 15</a:t>
-            </a:r>
-            <a:endParaRPr lang="en-US" sz="1700" dirty="0"/>
-          </a:p>
-          <a:p>
-            <a:pPr indent="0" marL="0">
-              <a:buNone/>
-            </a:pPr>
-            <a:r>
-              <a:rPr lang="en-US" sz="1700" dirty="0">
-                <a:solidFill>
-                  <a:schemeClr val="accent6"/>
-                </a:solidFill>
-              </a:rPr>
-              <a:t>Un INSERT fallido ya había consumido el autoincremento.</a:t>
-            </a:r>
-            <a:endParaRPr lang="en-US" sz="1700" dirty="0"/>
-          </a:p>
-        </p:txBody>
-      </p:sp>
-      <p:sp>
-        <p:nvSpPr>
-          <p:cNvPr id="10" name="Insignia 3"/>
-          <p:cNvSpPr/>
-          <p:nvPr/>
-        </p:nvSpPr>
-        <p:spPr>
-          <a:xfrm>
-            <a:off x="548640" y="4407408"/>
-            <a:ext cx="502920" cy="502920"/>
-          </a:xfrm>
-          <a:prstGeom prst="ellipse">
-            <a:avLst/>
-          </a:prstGeom>
-          <a:solidFill>
-            <a:schemeClr val="accent3"/>
-          </a:solidFill>
-          <a:ln/>
-        </p:spPr>
-      </p:sp>
-      <p:sp>
-        <p:nvSpPr>
-          <p:cNvPr id="11" name="Insignia texto 3"/>
-          <p:cNvSpPr txBox="1"/>
-          <p:nvPr/>
-        </p:nvSpPr>
-        <p:spPr>
-          <a:xfrm>
-            <a:off x="548640" y="4407408"/>
-            <a:ext cx="502920" cy="502920"/>
-          </a:xfrm>
-          <a:prstGeom prst="rect">
-            <a:avLst/>
-          </a:prstGeom>
-          <a:noFill/>
-          <a:ln/>
-        </p:spPr>
-        <p:txBody>
-          <a:bodyPr wrap="square" lIns="0" tIns="0" rIns="0" bIns="0" rtlCol="0" anchor="ctr"/>
-          <a:lstStyle/>
-          <a:p>
-            <a:pPr algn="ctr" indent="0" marL="0">
-              <a:buNone/>
-            </a:pPr>
-            <a:r>
-              <a:rPr lang="en-US" sz="1600" b="1" dirty="0">
-                <a:solidFill>
-                  <a:schemeClr val="bg1"/>
-                </a:solidFill>
-              </a:rPr>
-              <a:t>3</a:t>
-            </a:r>
-            <a:endParaRPr lang="en-US" sz="1600" dirty="0"/>
-          </a:p>
-        </p:txBody>
-      </p:sp>
-      <p:sp>
-        <p:nvSpPr>
-          <p:cNvPr id="12" name="Fila 3"/>
-          <p:cNvSpPr txBox="1"/>
-          <p:nvPr/>
-        </p:nvSpPr>
-        <p:spPr>
-          <a:xfrm>
-            <a:off x="1234440" y="4389120"/>
-            <a:ext cx="4709160" cy="777240"/>
-          </a:xfrm>
-          <a:prstGeom prst="rect">
-            <a:avLst/>
-          </a:prstGeom>
-          <a:noFill/>
-          <a:ln/>
-        </p:spPr>
-        <p:txBody>
-          <a:bodyPr wrap="square" lIns="0" tIns="0" rIns="0" bIns="0" rtlCol="0" anchor="t"/>
-          <a:lstStyle/>
-          <a:p>
-            <a:pPr indent="0" marL="0">
-              <a:buNone/>
-            </a:pPr>
-            <a:r>
-              <a:rPr lang="en-US" sz="1700" b="1" dirty="0">
-                <a:solidFill>
-                  <a:schemeClr val="tx1"/>
-                </a:solidFill>
-              </a:rPr>
-              <a:t>Envió «saó» sin codificar en la URL</a:t>
-            </a:r>
-            <a:endParaRPr lang="en-US" sz="1700" dirty="0"/>
-          </a:p>
-          <a:p>
-            <a:pPr indent="0" marL="0">
-              <a:buNone/>
-            </a:pPr>
-            <a:r>
-              <a:rPr lang="en-US" sz="1700" dirty="0">
-                <a:solidFill>
-                  <a:schemeClr val="accent6"/>
-                </a:solidFill>
-              </a:rPr>
-              <a:t>La prueba estaba mal; la aplicación funcionaba.</a:t>
-            </a:r>
-            <a:endParaRPr lang="en-US" sz="1700" dirty="0"/>
-          </a:p>
-        </p:txBody>
-      </p:sp>
-      <p:sp>
-        <p:nvSpPr>
-          <p:cNvPr id="13" name="Insignia 4"/>
-          <p:cNvSpPr/>
-          <p:nvPr/>
-        </p:nvSpPr>
-        <p:spPr>
-          <a:xfrm>
-            <a:off x="6217920" y="2029968"/>
-            <a:ext cx="502920" cy="502920"/>
-          </a:xfrm>
-          <a:prstGeom prst="ellipse">
-            <a:avLst/>
-          </a:prstGeom>
-          <a:solidFill>
-            <a:schemeClr val="accent3"/>
-          </a:solidFill>
-          <a:ln/>
-        </p:spPr>
-      </p:sp>
-      <p:sp>
-        <p:nvSpPr>
-          <p:cNvPr id="14" name="Insignia texto 4"/>
-          <p:cNvSpPr txBox="1"/>
-          <p:nvPr/>
-        </p:nvSpPr>
-        <p:spPr>
-          <a:xfrm>
-            <a:off x="6217920" y="2029968"/>
-            <a:ext cx="502920" cy="502920"/>
-          </a:xfrm>
-          <a:prstGeom prst="rect">
-            <a:avLst/>
-          </a:prstGeom>
-          <a:noFill/>
-          <a:ln/>
-        </p:spPr>
-        <p:txBody>
-          <a:bodyPr wrap="square" lIns="0" tIns="0" rIns="0" bIns="0" rtlCol="0" anchor="ctr"/>
-          <a:lstStyle/>
-          <a:p>
-            <a:pPr algn="ctr" indent="0" marL="0">
-              <a:buNone/>
-            </a:pPr>
-            <a:r>
-              <a:rPr lang="en-US" sz="1600" b="1" dirty="0">
-                <a:solidFill>
-                  <a:schemeClr val="bg1"/>
-                </a:solidFill>
-              </a:rPr>
-              <a:t>4</a:t>
-            </a:r>
-            <a:endParaRPr lang="en-US" sz="1600" dirty="0"/>
-          </a:p>
-        </p:txBody>
-      </p:sp>
-      <p:sp>
-        <p:nvSpPr>
-          <p:cNvPr id="15" name="Fila 4"/>
-          <p:cNvSpPr txBox="1"/>
-          <p:nvPr/>
-        </p:nvSpPr>
-        <p:spPr>
-          <a:xfrm>
-            <a:off x="6903720" y="2011680"/>
-            <a:ext cx="4709160" cy="777240"/>
-          </a:xfrm>
-          <a:prstGeom prst="rect">
-            <a:avLst/>
-          </a:prstGeom>
-          <a:noFill/>
-          <a:ln/>
-        </p:spPr>
-        <p:txBody>
-          <a:bodyPr wrap="square" lIns="0" tIns="0" rIns="0" bIns="0" rtlCol="0" anchor="t"/>
-          <a:lstStyle/>
-          <a:p>
-            <a:pPr indent="0" marL="0">
-              <a:buNone/>
-            </a:pPr>
-            <a:r>
-              <a:rPr lang="en-US" sz="1700" b="1" dirty="0">
-                <a:solidFill>
-                  <a:schemeClr val="tx1"/>
-                </a:solidFill>
-              </a:rPr>
-              <a:t>Esperaba un 404 en /../config</a:t>
-            </a:r>
-            <a:endParaRPr lang="en-US" sz="1700" dirty="0"/>
-          </a:p>
-          <a:p>
-            <a:pPr indent="0" marL="0">
-              <a:buNone/>
-            </a:pPr>
-            <a:r>
-              <a:rPr lang="en-US" sz="1700" dirty="0">
-                <a:solidFill>
-                  <a:schemeClr val="accent6"/>
-                </a:solidFill>
-              </a:rPr>
-              <a:t>Ahora la prueba comprueba que no se filtra el contenido.</a:t>
-            </a:r>
-            <a:endParaRPr lang="en-US" sz="1700" dirty="0"/>
-          </a:p>
-        </p:txBody>
-      </p:sp>
-      <p:sp>
-        <p:nvSpPr>
-          <p:cNvPr id="16" name="Insignia 5"/>
-          <p:cNvSpPr/>
-          <p:nvPr/>
-        </p:nvSpPr>
-        <p:spPr>
-          <a:xfrm>
-            <a:off x="6217920" y="3218688"/>
-            <a:ext cx="502920" cy="502920"/>
-          </a:xfrm>
-          <a:prstGeom prst="ellipse">
-            <a:avLst/>
-          </a:prstGeom>
-          <a:solidFill>
-            <a:schemeClr val="accent3"/>
-          </a:solidFill>
-          <a:ln/>
-        </p:spPr>
-      </p:sp>
-      <p:sp>
-        <p:nvSpPr>
-          <p:cNvPr id="17" name="Insignia texto 5"/>
-          <p:cNvSpPr txBox="1"/>
-          <p:nvPr/>
-        </p:nvSpPr>
-        <p:spPr>
-          <a:xfrm>
-            <a:off x="6217920" y="3218688"/>
-            <a:ext cx="502920" cy="502920"/>
-          </a:xfrm>
-          <a:prstGeom prst="rect">
-            <a:avLst/>
-          </a:prstGeom>
-          <a:noFill/>
-          <a:ln/>
-        </p:spPr>
-        <p:txBody>
-          <a:bodyPr wrap="square" lIns="0" tIns="0" rIns="0" bIns="0" rtlCol="0" anchor="ctr"/>
-          <a:lstStyle/>
-          <a:p>
-            <a:pPr algn="ctr" indent="0" marL="0">
-              <a:buNone/>
-            </a:pPr>
-            <a:r>
-              <a:rPr lang="en-US" sz="1600" b="1" dirty="0">
-                <a:solidFill>
-                  <a:schemeClr val="bg1"/>
-                </a:solidFill>
-              </a:rPr>
-              <a:t>5</a:t>
-            </a:r>
-            <a:endParaRPr lang="en-US" sz="1600" dirty="0"/>
-          </a:p>
-        </p:txBody>
-      </p:sp>
-      <p:sp>
-        <p:nvSpPr>
-          <p:cNvPr id="18" name="Fila 5"/>
-          <p:cNvSpPr txBox="1"/>
-          <p:nvPr/>
-        </p:nvSpPr>
-        <p:spPr>
-          <a:xfrm>
-            <a:off x="6903720" y="3200400"/>
-            <a:ext cx="4709160" cy="777240"/>
-          </a:xfrm>
-          <a:prstGeom prst="rect">
-            <a:avLst/>
-          </a:prstGeom>
-          <a:noFill/>
-          <a:ln/>
-        </p:spPr>
-        <p:txBody>
-          <a:bodyPr wrap="square" lIns="0" tIns="0" rIns="0" bIns="0" rtlCol="0" anchor="t"/>
-          <a:lstStyle/>
-          <a:p>
-            <a:pPr indent="0" marL="0">
-              <a:buNone/>
-            </a:pPr>
-            <a:r>
-              <a:rPr lang="en-US" sz="1700" b="1" dirty="0">
-                <a:solidFill>
-                  <a:schemeClr val="tx1"/>
-                </a:solidFill>
-              </a:rPr>
-              <a:t>Comparó con false en PHP 8.3</a:t>
-            </a:r>
-            <a:endParaRPr lang="en-US" sz="1700" dirty="0"/>
-          </a:p>
-          <a:p>
-            <a:pPr indent="0" marL="0">
-              <a:buNone/>
-            </a:pPr>
-            <a:r>
-              <a:rPr lang="en-US" sz="1700" dirty="0">
-                <a:solidFill>
-                  <a:schemeClr val="accent6"/>
-                </a:solidFill>
-              </a:rPr>
-              <a:t>PHP 8.3 devuelve 0; 8.4 devuelve false. Se encontró solo al probar en Docker.</a:t>
-            </a:r>
-            <a:endParaRPr lang="en-US" sz="1700" dirty="0"/>
           </a:p>
         </p:txBody>
       </p:sp>
@@ -5422,6 +5319,680 @@
         </p:nvSpPr>
         <p:spPr>
           <a:xfrm>
+            <a:off x="548640" y="320040"/>
+            <a:ext cx="11094415" cy="777240"/>
+          </a:xfrm>
+          <a:prstGeom prst="rect">
+            <a:avLst/>
+          </a:prstGeom>
+          <a:noFill/>
+          <a:ln/>
+        </p:spPr>
+        <p:txBody>
+          <a:bodyPr wrap="square" lIns="0" tIns="0" rIns="0" bIns="0" rtlCol="0" anchor="ctr"/>
+          <a:lstStyle/>
+          <a:p>
+            <a:pPr indent="0" marL="0">
+              <a:buNone/>
+            </a:pPr>
+            <a:r>
+              <a:rPr lang="en-US" sz="3000" b="1" dirty="0">
+                <a:solidFill>
+                  <a:schemeClr val="tx2"/>
+                </a:solidFill>
+              </a:rPr>
+              <a:t>Lo que nos enseñó trabajar con inteligencia artificial</a:t>
+            </a:r>
+            <a:endParaRPr lang="en-US" sz="3000" dirty="0"/>
+          </a:p>
+        </p:txBody>
+      </p:sp>
+      <p:sp>
+        <p:nvSpPr>
+          <p:cNvPr id="3" name="Introducción IA"/>
+          <p:cNvSpPr txBox="1"/>
+          <p:nvPr/>
+        </p:nvSpPr>
+        <p:spPr>
+          <a:xfrm>
+            <a:off x="548640" y="1280160"/>
+            <a:ext cx="11094415" cy="457200"/>
+          </a:xfrm>
+          <a:prstGeom prst="rect">
+            <a:avLst/>
+          </a:prstGeom>
+          <a:noFill/>
+          <a:ln/>
+        </p:spPr>
+        <p:txBody>
+          <a:bodyPr wrap="square" lIns="0" tIns="0" rIns="0" bIns="0" rtlCol="0" anchor="ctr"/>
+          <a:lstStyle/>
+          <a:p>
+            <a:pPr indent="0" marL="0">
+              <a:buNone/>
+            </a:pPr>
+            <a:r>
+              <a:rPr lang="en-US" sz="1700" dirty="0">
+                <a:solidFill>
+                  <a:schemeClr val="tx1"/>
+                </a:solidFill>
+              </a:rPr>
+              <a:t>La IA propone, el equipo decide. Cinco propuestas tenían errores, y las pruebas los detectaron:</a:t>
+            </a:r>
+            <a:endParaRPr lang="en-US" sz="1700" dirty="0"/>
+          </a:p>
+        </p:txBody>
+      </p:sp>
+      <p:sp>
+        <p:nvSpPr>
+          <p:cNvPr id="4" name="Insignia 1"/>
+          <p:cNvSpPr/>
+          <p:nvPr/>
+        </p:nvSpPr>
+        <p:spPr>
+          <a:xfrm>
+            <a:off x="548640" y="2029968"/>
+            <a:ext cx="502920" cy="502920"/>
+          </a:xfrm>
+          <a:prstGeom prst="ellipse">
+            <a:avLst/>
+          </a:prstGeom>
+          <a:solidFill>
+            <a:schemeClr val="accent3"/>
+          </a:solidFill>
+          <a:ln/>
+        </p:spPr>
+      </p:sp>
+      <p:sp>
+        <p:nvSpPr>
+          <p:cNvPr id="5" name="Insignia texto 1"/>
+          <p:cNvSpPr txBox="1"/>
+          <p:nvPr/>
+        </p:nvSpPr>
+        <p:spPr>
+          <a:xfrm>
+            <a:off x="548640" y="2029968"/>
+            <a:ext cx="502920" cy="502920"/>
+          </a:xfrm>
+          <a:prstGeom prst="rect">
+            <a:avLst/>
+          </a:prstGeom>
+          <a:noFill/>
+          <a:ln/>
+        </p:spPr>
+        <p:txBody>
+          <a:bodyPr wrap="square" lIns="0" tIns="0" rIns="0" bIns="0" rtlCol="0" anchor="ctr"/>
+          <a:lstStyle/>
+          <a:p>
+            <a:pPr algn="ctr" indent="0" marL="0">
+              <a:buNone/>
+            </a:pPr>
+            <a:r>
+              <a:rPr lang="en-US" sz="1600" b="1" dirty="0">
+                <a:solidFill>
+                  <a:schemeClr val="bg1"/>
+                </a:solidFill>
+              </a:rPr>
+              <a:t>1</a:t>
+            </a:r>
+            <a:endParaRPr lang="en-US" sz="1600" dirty="0"/>
+          </a:p>
+        </p:txBody>
+      </p:sp>
+      <p:sp>
+        <p:nvSpPr>
+          <p:cNvPr id="6" name="Fila 1"/>
+          <p:cNvSpPr txBox="1"/>
+          <p:nvPr/>
+        </p:nvSpPr>
+        <p:spPr>
+          <a:xfrm>
+            <a:off x="1234440" y="2011680"/>
+            <a:ext cx="4709160" cy="777240"/>
+          </a:xfrm>
+          <a:prstGeom prst="rect">
+            <a:avLst/>
+          </a:prstGeom>
+          <a:noFill/>
+          <a:ln/>
+        </p:spPr>
+        <p:txBody>
+          <a:bodyPr wrap="square" lIns="0" tIns="0" rIns="0" bIns="0" rtlCol="0" anchor="t"/>
+          <a:lstStyle/>
+          <a:p>
+            <a:pPr indent="0" marL="0">
+              <a:buNone/>
+            </a:pPr>
+            <a:r>
+              <a:rPr lang="en-US" sz="1700" b="1" dirty="0">
+                <a:solidFill>
+                  <a:schemeClr val="tx1"/>
+                </a:solidFill>
+              </a:rPr>
+              <a:t>Contó 5 claves foráneas</a:t>
+            </a:r>
+            <a:endParaRPr lang="en-US" sz="1700" dirty="0"/>
+          </a:p>
+          <a:p>
+            <a:pPr indent="0" marL="0">
+              <a:buNone/>
+            </a:pPr>
+            <a:r>
+              <a:rPr lang="en-US" sz="1700" dirty="0">
+                <a:solidFill>
+                  <a:schemeClr val="accent6"/>
+                </a:solidFill>
+              </a:rPr>
+              <a:t>El esquema tiene 4.</a:t>
+            </a:r>
+            <a:endParaRPr lang="en-US" sz="1700" dirty="0"/>
+          </a:p>
+        </p:txBody>
+      </p:sp>
+      <p:sp>
+        <p:nvSpPr>
+          <p:cNvPr id="7" name="Insignia 2"/>
+          <p:cNvSpPr/>
+          <p:nvPr/>
+        </p:nvSpPr>
+        <p:spPr>
+          <a:xfrm>
+            <a:off x="548640" y="3218688"/>
+            <a:ext cx="502920" cy="502920"/>
+          </a:xfrm>
+          <a:prstGeom prst="ellipse">
+            <a:avLst/>
+          </a:prstGeom>
+          <a:solidFill>
+            <a:schemeClr val="accent3"/>
+          </a:solidFill>
+          <a:ln/>
+        </p:spPr>
+      </p:sp>
+      <p:sp>
+        <p:nvSpPr>
+          <p:cNvPr id="8" name="Insignia texto 2"/>
+          <p:cNvSpPr txBox="1"/>
+          <p:nvPr/>
+        </p:nvSpPr>
+        <p:spPr>
+          <a:xfrm>
+            <a:off x="548640" y="3218688"/>
+            <a:ext cx="502920" cy="502920"/>
+          </a:xfrm>
+          <a:prstGeom prst="rect">
+            <a:avLst/>
+          </a:prstGeom>
+          <a:noFill/>
+          <a:ln/>
+        </p:spPr>
+        <p:txBody>
+          <a:bodyPr wrap="square" lIns="0" tIns="0" rIns="0" bIns="0" rtlCol="0" anchor="ctr"/>
+          <a:lstStyle/>
+          <a:p>
+            <a:pPr algn="ctr" indent="0" marL="0">
+              <a:buNone/>
+            </a:pPr>
+            <a:r>
+              <a:rPr lang="en-US" sz="1600" b="1" dirty="0">
+                <a:solidFill>
+                  <a:schemeClr val="bg1"/>
+                </a:solidFill>
+              </a:rPr>
+              <a:t>2</a:t>
+            </a:r>
+            <a:endParaRPr lang="en-US" sz="1600" dirty="0"/>
+          </a:p>
+        </p:txBody>
+      </p:sp>
+      <p:sp>
+        <p:nvSpPr>
+          <p:cNvPr id="9" name="Fila 2"/>
+          <p:cNvSpPr txBox="1"/>
+          <p:nvPr/>
+        </p:nvSpPr>
+        <p:spPr>
+          <a:xfrm>
+            <a:off x="1234440" y="3200400"/>
+            <a:ext cx="4709160" cy="777240"/>
+          </a:xfrm>
+          <a:prstGeom prst="rect">
+            <a:avLst/>
+          </a:prstGeom>
+          <a:noFill/>
+          <a:ln/>
+        </p:spPr>
+        <p:txBody>
+          <a:bodyPr wrap="square" lIns="0" tIns="0" rIns="0" bIns="0" rtlCol="0" anchor="t"/>
+          <a:lstStyle/>
+          <a:p>
+            <a:pPr indent="0" marL="0">
+              <a:buNone/>
+            </a:pPr>
+            <a:r>
+              <a:rPr lang="en-US" sz="1700" b="1" dirty="0">
+                <a:solidFill>
+                  <a:schemeClr val="tx1"/>
+                </a:solidFill>
+              </a:rPr>
+              <a:t>Supuso que la prenda nueva tendría id 15</a:t>
+            </a:r>
+            <a:endParaRPr lang="en-US" sz="1700" dirty="0"/>
+          </a:p>
+          <a:p>
+            <a:pPr indent="0" marL="0">
+              <a:buNone/>
+            </a:pPr>
+            <a:r>
+              <a:rPr lang="en-US" sz="1700" dirty="0">
+                <a:solidFill>
+                  <a:schemeClr val="accent6"/>
+                </a:solidFill>
+              </a:rPr>
+              <a:t>Un INSERT fallido ya había consumido el autoincremento.</a:t>
+            </a:r>
+            <a:endParaRPr lang="en-US" sz="1700" dirty="0"/>
+          </a:p>
+        </p:txBody>
+      </p:sp>
+      <p:sp>
+        <p:nvSpPr>
+          <p:cNvPr id="10" name="Insignia 3"/>
+          <p:cNvSpPr/>
+          <p:nvPr/>
+        </p:nvSpPr>
+        <p:spPr>
+          <a:xfrm>
+            <a:off x="548640" y="4407408"/>
+            <a:ext cx="502920" cy="502920"/>
+          </a:xfrm>
+          <a:prstGeom prst="ellipse">
+            <a:avLst/>
+          </a:prstGeom>
+          <a:solidFill>
+            <a:schemeClr val="accent3"/>
+          </a:solidFill>
+          <a:ln/>
+        </p:spPr>
+      </p:sp>
+      <p:sp>
+        <p:nvSpPr>
+          <p:cNvPr id="11" name="Insignia texto 3"/>
+          <p:cNvSpPr txBox="1"/>
+          <p:nvPr/>
+        </p:nvSpPr>
+        <p:spPr>
+          <a:xfrm>
+            <a:off x="548640" y="4407408"/>
+            <a:ext cx="502920" cy="502920"/>
+          </a:xfrm>
+          <a:prstGeom prst="rect">
+            <a:avLst/>
+          </a:prstGeom>
+          <a:noFill/>
+          <a:ln/>
+        </p:spPr>
+        <p:txBody>
+          <a:bodyPr wrap="square" lIns="0" tIns="0" rIns="0" bIns="0" rtlCol="0" anchor="ctr"/>
+          <a:lstStyle/>
+          <a:p>
+            <a:pPr algn="ctr" indent="0" marL="0">
+              <a:buNone/>
+            </a:pPr>
+            <a:r>
+              <a:rPr lang="en-US" sz="1600" b="1" dirty="0">
+                <a:solidFill>
+                  <a:schemeClr val="bg1"/>
+                </a:solidFill>
+              </a:rPr>
+              <a:t>3</a:t>
+            </a:r>
+            <a:endParaRPr lang="en-US" sz="1600" dirty="0"/>
+          </a:p>
+        </p:txBody>
+      </p:sp>
+      <p:sp>
+        <p:nvSpPr>
+          <p:cNvPr id="12" name="Fila 3"/>
+          <p:cNvSpPr txBox="1"/>
+          <p:nvPr/>
+        </p:nvSpPr>
+        <p:spPr>
+          <a:xfrm>
+            <a:off x="1234440" y="4389120"/>
+            <a:ext cx="4709160" cy="777240"/>
+          </a:xfrm>
+          <a:prstGeom prst="rect">
+            <a:avLst/>
+          </a:prstGeom>
+          <a:noFill/>
+          <a:ln/>
+        </p:spPr>
+        <p:txBody>
+          <a:bodyPr wrap="square" lIns="0" tIns="0" rIns="0" bIns="0" rtlCol="0" anchor="t"/>
+          <a:lstStyle/>
+          <a:p>
+            <a:pPr indent="0" marL="0">
+              <a:buNone/>
+            </a:pPr>
+            <a:r>
+              <a:rPr lang="en-US" sz="1700" b="1" dirty="0">
+                <a:solidFill>
+                  <a:schemeClr val="tx1"/>
+                </a:solidFill>
+              </a:rPr>
+              <a:t>Envió «saó» sin codificar en la URL</a:t>
+            </a:r>
+            <a:endParaRPr lang="en-US" sz="1700" dirty="0"/>
+          </a:p>
+          <a:p>
+            <a:pPr indent="0" marL="0">
+              <a:buNone/>
+            </a:pPr>
+            <a:r>
+              <a:rPr lang="en-US" sz="1700" dirty="0">
+                <a:solidFill>
+                  <a:schemeClr val="accent6"/>
+                </a:solidFill>
+              </a:rPr>
+              <a:t>La prueba estaba mal; la aplicación funcionaba.</a:t>
+            </a:r>
+            <a:endParaRPr lang="en-US" sz="1700" dirty="0"/>
+          </a:p>
+        </p:txBody>
+      </p:sp>
+      <p:sp>
+        <p:nvSpPr>
+          <p:cNvPr id="13" name="Insignia 4"/>
+          <p:cNvSpPr/>
+          <p:nvPr/>
+        </p:nvSpPr>
+        <p:spPr>
+          <a:xfrm>
+            <a:off x="6217920" y="2029968"/>
+            <a:ext cx="502920" cy="502920"/>
+          </a:xfrm>
+          <a:prstGeom prst="ellipse">
+            <a:avLst/>
+          </a:prstGeom>
+          <a:solidFill>
+            <a:schemeClr val="accent3"/>
+          </a:solidFill>
+          <a:ln/>
+        </p:spPr>
+      </p:sp>
+      <p:sp>
+        <p:nvSpPr>
+          <p:cNvPr id="14" name="Insignia texto 4"/>
+          <p:cNvSpPr txBox="1"/>
+          <p:nvPr/>
+        </p:nvSpPr>
+        <p:spPr>
+          <a:xfrm>
+            <a:off x="6217920" y="2029968"/>
+            <a:ext cx="502920" cy="502920"/>
+          </a:xfrm>
+          <a:prstGeom prst="rect">
+            <a:avLst/>
+          </a:prstGeom>
+          <a:noFill/>
+          <a:ln/>
+        </p:spPr>
+        <p:txBody>
+          <a:bodyPr wrap="square" lIns="0" tIns="0" rIns="0" bIns="0" rtlCol="0" anchor="ctr"/>
+          <a:lstStyle/>
+          <a:p>
+            <a:pPr algn="ctr" indent="0" marL="0">
+              <a:buNone/>
+            </a:pPr>
+            <a:r>
+              <a:rPr lang="en-US" sz="1600" b="1" dirty="0">
+                <a:solidFill>
+                  <a:schemeClr val="bg1"/>
+                </a:solidFill>
+              </a:rPr>
+              <a:t>4</a:t>
+            </a:r>
+            <a:endParaRPr lang="en-US" sz="1600" dirty="0"/>
+          </a:p>
+        </p:txBody>
+      </p:sp>
+      <p:sp>
+        <p:nvSpPr>
+          <p:cNvPr id="15" name="Fila 4"/>
+          <p:cNvSpPr txBox="1"/>
+          <p:nvPr/>
+        </p:nvSpPr>
+        <p:spPr>
+          <a:xfrm>
+            <a:off x="6903720" y="2011680"/>
+            <a:ext cx="4709160" cy="777240"/>
+          </a:xfrm>
+          <a:prstGeom prst="rect">
+            <a:avLst/>
+          </a:prstGeom>
+          <a:noFill/>
+          <a:ln/>
+        </p:spPr>
+        <p:txBody>
+          <a:bodyPr wrap="square" lIns="0" tIns="0" rIns="0" bIns="0" rtlCol="0" anchor="t"/>
+          <a:lstStyle/>
+          <a:p>
+            <a:pPr indent="0" marL="0">
+              <a:buNone/>
+            </a:pPr>
+            <a:r>
+              <a:rPr lang="en-US" sz="1700" b="1" dirty="0">
+                <a:solidFill>
+                  <a:schemeClr val="tx1"/>
+                </a:solidFill>
+              </a:rPr>
+              <a:t>Esperaba un 404 en /../config</a:t>
+            </a:r>
+            <a:endParaRPr lang="en-US" sz="1700" dirty="0"/>
+          </a:p>
+          <a:p>
+            <a:pPr indent="0" marL="0">
+              <a:buNone/>
+            </a:pPr>
+            <a:r>
+              <a:rPr lang="en-US" sz="1700" dirty="0">
+                <a:solidFill>
+                  <a:schemeClr val="accent6"/>
+                </a:solidFill>
+              </a:rPr>
+              <a:t>Ahora la prueba comprueba que no se filtra el contenido.</a:t>
+            </a:r>
+            <a:endParaRPr lang="en-US" sz="1700" dirty="0"/>
+          </a:p>
+        </p:txBody>
+      </p:sp>
+      <p:sp>
+        <p:nvSpPr>
+          <p:cNvPr id="16" name="Insignia 5"/>
+          <p:cNvSpPr/>
+          <p:nvPr/>
+        </p:nvSpPr>
+        <p:spPr>
+          <a:xfrm>
+            <a:off x="6217920" y="3218688"/>
+            <a:ext cx="502920" cy="502920"/>
+          </a:xfrm>
+          <a:prstGeom prst="ellipse">
+            <a:avLst/>
+          </a:prstGeom>
+          <a:solidFill>
+            <a:schemeClr val="accent3"/>
+          </a:solidFill>
+          <a:ln/>
+        </p:spPr>
+      </p:sp>
+      <p:sp>
+        <p:nvSpPr>
+          <p:cNvPr id="17" name="Insignia texto 5"/>
+          <p:cNvSpPr txBox="1"/>
+          <p:nvPr/>
+        </p:nvSpPr>
+        <p:spPr>
+          <a:xfrm>
+            <a:off x="6217920" y="3218688"/>
+            <a:ext cx="502920" cy="502920"/>
+          </a:xfrm>
+          <a:prstGeom prst="rect">
+            <a:avLst/>
+          </a:prstGeom>
+          <a:noFill/>
+          <a:ln/>
+        </p:spPr>
+        <p:txBody>
+          <a:bodyPr wrap="square" lIns="0" tIns="0" rIns="0" bIns="0" rtlCol="0" anchor="ctr"/>
+          <a:lstStyle/>
+          <a:p>
+            <a:pPr algn="ctr" indent="0" marL="0">
+              <a:buNone/>
+            </a:pPr>
+            <a:r>
+              <a:rPr lang="en-US" sz="1600" b="1" dirty="0">
+                <a:solidFill>
+                  <a:schemeClr val="bg1"/>
+                </a:solidFill>
+              </a:rPr>
+              <a:t>5</a:t>
+            </a:r>
+            <a:endParaRPr lang="en-US" sz="1600" dirty="0"/>
+          </a:p>
+        </p:txBody>
+      </p:sp>
+      <p:sp>
+        <p:nvSpPr>
+          <p:cNvPr id="18" name="Fila 5"/>
+          <p:cNvSpPr txBox="1"/>
+          <p:nvPr/>
+        </p:nvSpPr>
+        <p:spPr>
+          <a:xfrm>
+            <a:off x="6903720" y="3200400"/>
+            <a:ext cx="4709160" cy="777240"/>
+          </a:xfrm>
+          <a:prstGeom prst="rect">
+            <a:avLst/>
+          </a:prstGeom>
+          <a:noFill/>
+          <a:ln/>
+        </p:spPr>
+        <p:txBody>
+          <a:bodyPr wrap="square" lIns="0" tIns="0" rIns="0" bIns="0" rtlCol="0" anchor="t"/>
+          <a:lstStyle/>
+          <a:p>
+            <a:pPr indent="0" marL="0">
+              <a:buNone/>
+            </a:pPr>
+            <a:r>
+              <a:rPr lang="en-US" sz="1700" b="1" dirty="0">
+                <a:solidFill>
+                  <a:schemeClr val="tx1"/>
+                </a:solidFill>
+              </a:rPr>
+              <a:t>Comparó con false en PHP 8.3</a:t>
+            </a:r>
+            <a:endParaRPr lang="en-US" sz="1700" dirty="0"/>
+          </a:p>
+          <a:p>
+            <a:pPr indent="0" marL="0">
+              <a:buNone/>
+            </a:pPr>
+            <a:r>
+              <a:rPr lang="en-US" sz="1700" dirty="0">
+                <a:solidFill>
+                  <a:schemeClr val="accent6"/>
+                </a:solidFill>
+              </a:rPr>
+              <a:t>PHP 8.3 devuelve 0; 8.4 devuelve false. Se encontró solo al probar en Docker.</a:t>
+            </a:r>
+            <a:endParaRPr lang="en-US" sz="1700" dirty="0"/>
+          </a:p>
+        </p:txBody>
+      </p:sp>
+      <p:sp>
+        <p:nvSpPr>
+          <p:cNvPr id="25" name="Slide Number Placeholder 0"/>
+          <p:cNvSpPr>
+            <a:spLocks noGrp="1"/>
+          </p:cNvSpPr>
+          <p:nvPr>
+            <p:ph type="sldNum" sz="quarter" idx="4294967295"/>
+          </p:nvPr>
+        </p:nvSpPr>
+        <p:spPr>
+          <a:xfrm>
+            <a:off x="11094415" y="6446520"/>
+            <a:ext cx="548640" cy="274320"/>
+          </a:xfrm>
+          <a:prstGeom prst="rect">
+            <a:avLst/>
+          </a:prstGeom>
+          <a:extLst>
+            <a:ext uri="{C572A759-6A51-4108-AA02-DFA0A04FC94B}">
+              <ma14:wrappingTextBoxFlag xmlns:ma14="http://schemas.microsoft.com/office/mac/drawingml/2011/main" val="0"/>
+            </a:ext>
+          </a:extLst>
+        </p:spPr>
+        <p:txBody>
+          <a:bodyPr/>
+          <a:lstStyle>
+            <a:lvl1pPr>
+              <a:defRPr sz="1000">
+                <a:solidFill>
+                  <a:schemeClr val="accent6"/>
+                </a:solidFill>
+              </a:defRPr>
+            </a:lvl1pPr>
+          </a:lstStyle>
+          <a:p>
+            <a:pPr algn="r"/>
+            <a:fld id="{F7021451-1387-4CA6-816F-3879F97B5CBC}" type="slidenum">
+              <a:rPr b="0" lang="en-US"/>
+              <a:t>13</a:t>
+            </a:fld>
+            <a:endParaRPr lang="en-US"/>
+          </a:p>
+        </p:txBody>
+      </p:sp>
+    </p:spTree>
+  </p:cSld>
+  <p:clrMapOvr>
+    <a:masterClrMapping/>
+  </p:clrMapOvr>
+</p:sld>
+</file>
+
+<file path=ppt/slides/slide14.xml><?xml version="1.0" encoding="utf-8"?>
+<p:sld xmlns:a="http://schemas.openxmlformats.org/drawingml/2006/main" xmlns:r="http://schemas.openxmlformats.org/officeDocument/2006/relationships" xmlns:p="http://schemas.openxmlformats.org/presentationml/2006/main">
+  <p:cSld name="Slide 14">
+    <p:spTree>
+      <p:nvGrpSpPr>
+        <p:cNvPr id="1" name=""/>
+        <p:cNvGrpSpPr/>
+        <p:nvPr/>
+      </p:nvGrpSpPr>
+      <p:grpSpPr>
+        <a:xfrm>
+          <a:off x="0" y="0"/>
+          <a:ext cx="0" cy="0"/>
+          <a:chOff x="0" y="0"/>
+          <a:chExt cx="0" cy="0"/>
+        </a:xfrm>
+      </p:grpSpPr>
+      <p:sp>
+        <p:nvSpPr>
+          <p:cNvPr id="2" name="Text 0"/>
+          <p:cNvSpPr/>
+          <p:nvPr>
+            <p:ph idx="100" type="title" hasCustomPrompt="1"/>
+          </p:nvPr>
+        </p:nvSpPr>
+        <p:spPr>
+          <a:xfrm>
             <a:off x="548640" y="411480"/>
             <a:ext cx="11094415" cy="822960"/>
           </a:xfrm>
@@ -5521,6 +6092,24 @@
                 </a:solidFill>
               </a:rPr>
               <a:t>Resiste la inyección SQL y lo demuestran 13 pruebas</a:t>
+            </a:r>
+            <a:endParaRPr lang="en-US" sz="2100" dirty="0"/>
+          </a:p>
+          <a:p>
+            <a:pPr marL="342900" indent="-342900">
+              <a:spcAft>
+                <a:spcPts val="800"/>
+              </a:spcAft>
+              <a:buSzPct val="100000"/>
+              <a:buChar char="•"/>
+            </a:pPr>
+            <a:r>
+              <a:rPr lang="en-US" sz="2100" dirty="0">
+                <a:solidFill>
+                  <a:schemeClr val="bg1"/>
+                </a:solidFill>
+              </a:rPr>
+              <a:t>Interfaz con modales y avisos, probada en el navegador</a:t>
             </a:r>
             <a:endParaRPr lang="en-US" sz="2100" dirty="0"/>
           </a:p>
@@ -6580,7 +7169,7 @@
           </a:prstGeom>
           <a:ln w="25400">
             <a:solidFill>
-              <a:srgbClr val="FBE9DF"/>
+              <a:srgbClr val="F8EEF0"/>
             </a:solidFill>
             <a:prstDash val="solid"/>
           </a:ln>
@@ -6713,7 +7302,7 @@
           </a:solidFill>
           <a:ln w="12700">
             <a:solidFill>
-              <a:srgbClr val="FBE9DF"/>
+              <a:srgbClr val="F8EEF0"/>
             </a:solidFill>
             <a:prstDash val="solid"/>
           </a:ln>
@@ -9183,7 +9772,7 @@
                   <a:schemeClr val="tx2"/>
                 </a:solidFill>
               </a:rPr>
-              <a:t>La tienda funciona igual, ahora sobre MySQL</a:t>
+              <a:t>La tienda sobre MySQL, con su nuevo diseño</a:t>
             </a:r>
             <a:endParaRPr lang="en-US" sz="3000" dirty="0"/>
           </a:p>
@@ -9208,7 +9797,7 @@
           </a:solidFill>
           <a:ln w="12700">
             <a:solidFill>
-              <a:srgbClr val="FBE9DF"/>
+              <a:srgbClr val="F8EEF0"/>
             </a:solidFill>
             <a:prstDash val="solid"/>
           </a:ln>
@@ -9264,7 +9853,7 @@
           </a:solidFill>
           <a:ln w="12700">
             <a:solidFill>
-              <a:srgbClr val="FBE9DF"/>
+              <a:srgbClr val="F8EEF0"/>
             </a:solidFill>
             <a:prstDash val="solid"/>
           </a:ln>
@@ -9500,7 +10089,7 @@
           </a:solidFill>
           <a:ln w="12700">
             <a:solidFill>
-              <a:srgbClr val="FBE9DF"/>
+              <a:srgbClr val="F8EEF0"/>
             </a:solidFill>
             <a:prstDash val="solid"/>
           </a:ln>
@@ -9556,7 +10145,7 @@
           </a:solidFill>
           <a:ln w="12700">
             <a:solidFill>
-              <a:srgbClr val="FBE9DF"/>
+              <a:srgbClr val="F8EEF0"/>
             </a:solidFill>
             <a:prstDash val="solid"/>
           </a:ln>
@@ -9659,7 +10248,7 @@
                   <a:schemeClr val="accent6"/>
                 </a:solidFill>
               </a:rPr>
-              <a:t>Respuesta 422: CI repetido, celular inválido y fecha futura, con el mensaje junto a cada campo.</a:t>
+              <a:t>Respuesta 422 dentro del modal: CI repetido, celular inválido y fecha futura, con el mensaje junto a cada campo.</a:t>
             </a:r>
             <a:endParaRPr lang="en-US" sz="1500" dirty="0"/>
           </a:p>
@@ -9723,40 +10312,40 @@
   <a:themeElements>
     <a:clrScheme name="Manos del Oriente">
       <a:dk1>
-        <a:srgbClr val="2B1A12"/>
+        <a:srgbClr val="2D2A32"/>
       </a:dk1>
       <a:lt1>
         <a:srgbClr val="FFFFFF"/>
       </a:lt1>
       <a:dk2>
-        <a:srgbClr val="7A2E14"/>
+        <a:srgbClr val="3B3542"/>
       </a:dk2>
       <a:lt2>
-        <a:srgbClr val="FBE9DF"/>
+        <a:srgbClr val="F8EEF0"/>
       </a:lt2>
       <a:accent1>
-        <a:srgbClr val="7A2E14"/>
+        <a:srgbClr val="A0566A"/>
       </a:accent1>
       <a:accent2>
-        <a:srgbClr val="0F766E"/>
+        <a:srgbClr val="4C7A69"/>
       </a:accent2>
       <a:accent3>
-        <a:srgbClr val="C2410C"/>
+        <a:srgbClr val="B5838D"/>
       </a:accent3>
       <a:accent4>
-        <a:srgbClr val="A16207"/>
+        <a:srgbClr val="7B6BA8"/>
       </a:accent4>
       <a:accent5>
-        <a:srgbClr val="9F1239"/>
+        <a:srgbClr val="C4647A"/>
       </a:accent5>
       <a:accent6>
-        <a:srgbClr val="6B5B53"/>
+        <a:srgbClr val="6B6570"/>
       </a:accent6>
       <a:hlink>
-        <a:srgbClr val="0F766E"/>
+        <a:srgbClr val="A0566A"/>
       </a:hlink>
       <a:folHlink>
-        <a:srgbClr val="7A2E14"/>
+        <a:srgbClr val="4C7A69"/>
       </a:folHlink>
     </a:clrScheme>
     <a:fontScheme name="Manos del Oriente">

</xml_diff>

<commit_message>
Integrantes completos en informes, presentaciones, README y bitácora
Daniela Cayo Mamani, Juan Jose Vicente Cossio, Ronald Salvatierra Flores,
Yordy Tolavi Ruiz y Alejandro Cadario Lopez.

Co-Authored-By: Claude Opus 5.5 <noreply@anthropic.com>
</commit_message>
<xml_diff>
--- a/docs/actividad-02/Presentacion_Actividad02.pptx
+++ b/docs/actividad-02/Presentacion_Actividad02.pptx
@@ -120,52 +120,52 @@
   <p:extLst>
     <p:ext uri="{521415D9-36F7-43E2-AB2F-B90AF26B5E84}">
       <p14:sectionLst xmlns:p14="http://schemas.microsoft.com/office/powerpoint/2010/main">
-        <p14:section name="Inicio" id="{bc14d560-7dbd-03a6-c2be-13484fa2a3e2}">
+        <p14:section name="Inicio" id="{9892cf91-bcf4-cb4d-ad97-af47f654efe4}">
           <p14:sldIdLst>
             <p14:sldId id="256"/>
           </p14:sldIdLst>
         </p14:section>
-        <p14:section name="Contexto" id="{17007429-4c08-6a6e-8606-9f8d188d5761}">
+        <p14:section name="Contexto" id="{9baa03ba-9449-ee77-624f-d484483d429a}">
           <p14:sldIdLst>
             <p14:sldId id="257"/>
             <p14:sldId id="258"/>
           </p14:sldIdLst>
         </p14:section>
-        <p14:section name="Base de datos" id="{4b199489-f951-461d-4451-8551cc423a08}">
+        <p14:section name="Base de datos" id="{32192eba-2727-7f12-b920-3480fdefed74}">
           <p14:sldIdLst>
             <p14:sldId id="259"/>
             <p14:sldId id="260"/>
           </p14:sldIdLst>
         </p14:section>
-        <p14:section name="Código" id="{6754d0c9-4994-c024-889e-29a39a7d3c95}">
+        <p14:section name="Código" id="{d66242b4-8dc4-137f-50c5-d87256f7ce03}">
           <p14:sldIdLst>
             <p14:sldId id="261"/>
             <p14:sldId id="262"/>
           </p14:sldIdLst>
         </p14:section>
-        <p14:section name="Aplicación" id="{b32ba191-02b9-9d73-c6ed-992ec82962b9}">
+        <p14:section name="Aplicación" id="{d5f90d88-99bb-96f3-5702-eb12c1969991}">
           <p14:sldIdLst>
             <p14:sldId id="263"/>
             <p14:sldId id="264"/>
             <p14:sldId id="265"/>
           </p14:sldIdLst>
         </p14:section>
-        <p14:section name="Seguridad" id="{e2c035ca-c8bc-3953-454e-865b2fc25d32}">
+        <p14:section name="Seguridad" id="{bed88138-d3a9-fdff-6075-911d91a28b9a}">
           <p14:sldIdLst>
             <p14:sldId id="266"/>
           </p14:sldIdLst>
         </p14:section>
-        <p14:section name="Pruebas" id="{eef10be1-9480-7fe9-de23-43ec31d810e8}">
+        <p14:section name="Pruebas" id="{811b019d-8ea8-a9ac-1ece-5660fd911215}">
           <p14:sldIdLst>
             <p14:sldId id="267"/>
           </p14:sldIdLst>
         </p14:section>
-        <p14:section name="Uso de IA" id="{1a392658-4035-2c89-1b5d-4dc0a605f608}">
+        <p14:section name="Uso de IA" id="{1c9a50c5-51ea-8293-aeeb-4cf887f489c7}">
           <p14:sldIdLst>
             <p14:sldId id="268"/>
           </p14:sldIdLst>
         </p14:section>
-        <p14:section name="Cierre" id="{8441c058-8897-dd2f-26f9-e5fa132f904d}">
+        <p14:section name="Cierre" id="{22141815-37d2-42db-1775-6d2543cf83c5}">
           <p14:sldIdLst>
             <p14:sldId id="269"/>
           </p14:sldIdLst>
@@ -2935,7 +2935,7 @@
                   <a:schemeClr val="bg2"/>
                 </a:solidFill>
               </a:rPr>
-              <a:t>Integrantes: Daniela Cayo Mamani · Juan Jose Vicente · Yordy Tolavi Ruiz · [Integrante 4] · [Integrante 5]</a:t>
+              <a:t>Integrantes: Daniela Cayo Mamani · Juan Jose Vicente Cossio · Ronald Salvatierra Flores · Yordy Tolavi Ruiz · Alejandro Cadario Lopez</a:t>
             </a:r>
             <a:endParaRPr lang="en-US" sz="1400" dirty="0"/>
           </a:p>

</xml_diff>